<commit_message>
docs: publish direct frontend-slides HTML deck
Co-authored-by: sushioo170506-ship-it <sushioo170506-ship-it@users.noreply.github.com>
</commit_message>
<xml_diff>
--- a/outputs/gpt-live-application-research/gpt-live-deck.pptx
+++ b/outputs/gpt-live-application-research/gpt-live-deck.pptx
@@ -3101,7 +3101,7 @@
     <p:bg>
       <p:bgPr>
         <a:solidFill>
-          <a:srgbClr val="07111F"/>
+          <a:srgbClr val="F4F1E8"/>
         </a:solidFill>
         <a:effectLst/>
       </p:bgPr>
@@ -3130,7 +3130,7 @@
           <a:noFill/>
           <a:ln>
             <a:solidFill>
-              <a:srgbClr val="46D6C8"/>
+              <a:srgbClr val="E6462E"/>
             </a:solidFill>
           </a:ln>
         </p:spPr>
@@ -3181,7 +3181,7 @@
             <a:pPr>
               <a:defRPr sz="1200" b="1">
                 <a:solidFill>
-                  <a:srgbClr val="46D6C8"/>
+                  <a:srgbClr val="E6462E"/>
                 </a:solidFill>
               </a:defRPr>
             </a:pPr>
@@ -3216,7 +3216,7 @@
             <a:pPr>
               <a:defRPr sz="4200" b="1">
                 <a:solidFill>
-                  <a:srgbClr val="F4F8FC"/>
+                  <a:srgbClr val="151515"/>
                 </a:solidFill>
               </a:defRPr>
             </a:pPr>
@@ -3251,7 +3251,7 @@
             <a:pPr>
               <a:defRPr sz="2000">
                 <a:solidFill>
-                  <a:srgbClr val="9AB2C8"/>
+                  <a:srgbClr val="62666A"/>
                 </a:solidFill>
               </a:defRPr>
             </a:pPr>
@@ -3286,7 +3286,7 @@
             <a:pPr>
               <a:defRPr sz="1000">
                 <a:solidFill>
-                  <a:srgbClr val="55A7FF"/>
+                  <a:srgbClr val="176B87"/>
                 </a:solidFill>
               </a:defRPr>
             </a:pPr>
@@ -3310,7 +3310,7 @@
     <p:bg>
       <p:bgPr>
         <a:solidFill>
-          <a:srgbClr val="07111F"/>
+          <a:srgbClr val="F4F1E8"/>
         </a:solidFill>
         <a:effectLst/>
       </p:bgPr>
@@ -3337,7 +3337,7 @@
             <a:avLst/>
           </a:prstGeom>
           <a:solidFill>
-            <a:srgbClr val="46D6C8"/>
+            <a:srgbClr val="E6462E"/>
           </a:solidFill>
           <a:ln>
             <a:noFill/>
@@ -3390,7 +3390,7 @@
             <a:pPr>
               <a:defRPr sz="900" b="1">
                 <a:solidFill>
-                  <a:srgbClr val="46D6C8"/>
+                  <a:srgbClr val="E6462E"/>
                 </a:solidFill>
               </a:defRPr>
             </a:pPr>
@@ -3425,7 +3425,7 @@
             <a:pPr algn="l">
               <a:defRPr sz="2700" b="1">
                 <a:solidFill>
-                  <a:srgbClr val="F4F8FC"/>
+                  <a:srgbClr val="151515"/>
                 </a:solidFill>
               </a:defRPr>
             </a:pPr>
@@ -3450,7 +3450,7 @@
             <a:avLst/>
           </a:prstGeom>
           <a:solidFill>
-            <a:srgbClr val="10243C"/>
+            <a:srgbClr val="FFFFFF"/>
           </a:solidFill>
           <a:ln>
             <a:solidFill>
@@ -3479,7 +3479,7 @@
             <a:pPr algn="ctr">
               <a:defRPr sz="1200" b="1">
                 <a:solidFill>
-                  <a:srgbClr val="46D6C8"/>
+                  <a:srgbClr val="E6462E"/>
                 </a:solidFill>
               </a:defRPr>
             </a:pPr>
@@ -3494,7 +3494,7 @@
               </a:spcBef>
               <a:defRPr sz="1500">
                 <a:solidFill>
-                  <a:srgbClr val="F4F8FC"/>
+                  <a:srgbClr val="151515"/>
                 </a:solidFill>
               </a:defRPr>
             </a:pPr>
@@ -3519,7 +3519,7 @@
             <a:avLst/>
           </a:prstGeom>
           <a:solidFill>
-            <a:srgbClr val="46D6C8"/>
+            <a:srgbClr val="E6462E"/>
           </a:solidFill>
           <a:ln>
             <a:noFill/>
@@ -3562,7 +3562,7 @@
             <a:avLst/>
           </a:prstGeom>
           <a:solidFill>
-            <a:srgbClr val="10243C"/>
+            <a:srgbClr val="FFFFFF"/>
           </a:solidFill>
           <a:ln>
             <a:solidFill>
@@ -3591,7 +3591,7 @@
             <a:pPr algn="ctr">
               <a:defRPr sz="1200" b="1">
                 <a:solidFill>
-                  <a:srgbClr val="55A7FF"/>
+                  <a:srgbClr val="176B87"/>
                 </a:solidFill>
               </a:defRPr>
             </a:pPr>
@@ -3606,7 +3606,7 @@
               </a:spcBef>
               <a:defRPr sz="1500">
                 <a:solidFill>
-                  <a:srgbClr val="F4F8FC"/>
+                  <a:srgbClr val="151515"/>
                 </a:solidFill>
               </a:defRPr>
             </a:pPr>
@@ -3631,7 +3631,7 @@
             <a:avLst/>
           </a:prstGeom>
           <a:solidFill>
-            <a:srgbClr val="55A7FF"/>
+            <a:srgbClr val="176B87"/>
           </a:solidFill>
           <a:ln>
             <a:noFill/>
@@ -3674,7 +3674,7 @@
             <a:avLst/>
           </a:prstGeom>
           <a:solidFill>
-            <a:srgbClr val="10243C"/>
+            <a:srgbClr val="FFFFFF"/>
           </a:solidFill>
           <a:ln>
             <a:solidFill>
@@ -3703,7 +3703,7 @@
             <a:pPr algn="ctr">
               <a:defRPr sz="1200" b="1">
                 <a:solidFill>
-                  <a:srgbClr val="FFBE55"/>
+                  <a:srgbClr val="D39A28"/>
                 </a:solidFill>
               </a:defRPr>
             </a:pPr>
@@ -3718,7 +3718,7 @@
               </a:spcBef>
               <a:defRPr sz="1500">
                 <a:solidFill>
-                  <a:srgbClr val="F4F8FC"/>
+                  <a:srgbClr val="151515"/>
                 </a:solidFill>
               </a:defRPr>
             </a:pPr>
@@ -3743,7 +3743,7 @@
             <a:avLst/>
           </a:prstGeom>
           <a:solidFill>
-            <a:srgbClr val="FFBE55"/>
+            <a:srgbClr val="D39A28"/>
           </a:solidFill>
           <a:ln>
             <a:noFill/>
@@ -3786,7 +3786,7 @@
             <a:avLst/>
           </a:prstGeom>
           <a:solidFill>
-            <a:srgbClr val="10243C"/>
+            <a:srgbClr val="FFFFFF"/>
           </a:solidFill>
           <a:ln>
             <a:solidFill>
@@ -3815,7 +3815,7 @@
             <a:pPr algn="ctr">
               <a:defRPr sz="1200" b="1">
                 <a:solidFill>
-                  <a:srgbClr val="46D6C8"/>
+                  <a:srgbClr val="E6462E"/>
                 </a:solidFill>
               </a:defRPr>
             </a:pPr>
@@ -3830,7 +3830,7 @@
               </a:spcBef>
               <a:defRPr sz="1500">
                 <a:solidFill>
-                  <a:srgbClr val="F4F8FC"/>
+                  <a:srgbClr val="151515"/>
                 </a:solidFill>
               </a:defRPr>
             </a:pPr>
@@ -3855,7 +3855,7 @@
             <a:avLst/>
           </a:prstGeom>
           <a:solidFill>
-            <a:srgbClr val="46D6C8"/>
+            <a:srgbClr val="E6462E"/>
           </a:solidFill>
           <a:ln>
             <a:noFill/>
@@ -3908,7 +3908,7 @@
             <a:pPr>
               <a:defRPr sz="900">
                 <a:solidFill>
-                  <a:srgbClr val="9AB2C8"/>
+                  <a:srgbClr val="62666A"/>
                 </a:solidFill>
               </a:defRPr>
             </a:pPr>
@@ -3932,7 +3932,7 @@
     <p:bg>
       <p:bgPr>
         <a:solidFill>
-          <a:srgbClr val="07111F"/>
+          <a:srgbClr val="F4F1E8"/>
         </a:solidFill>
         <a:effectLst/>
       </p:bgPr>
@@ -3959,7 +3959,7 @@
             <a:avLst/>
           </a:prstGeom>
           <a:solidFill>
-            <a:srgbClr val="46D6C8"/>
+            <a:srgbClr val="E6462E"/>
           </a:solidFill>
           <a:ln>
             <a:noFill/>
@@ -4012,7 +4012,7 @@
             <a:pPr>
               <a:defRPr sz="900" b="1">
                 <a:solidFill>
-                  <a:srgbClr val="46D6C8"/>
+                  <a:srgbClr val="E6462E"/>
                 </a:solidFill>
               </a:defRPr>
             </a:pPr>
@@ -4047,7 +4047,7 @@
             <a:pPr algn="l">
               <a:defRPr sz="2700" b="1">
                 <a:solidFill>
-                  <a:srgbClr val="F4F8FC"/>
+                  <a:srgbClr val="151515"/>
                 </a:solidFill>
               </a:defRPr>
             </a:pPr>
@@ -4072,7 +4072,7 @@
             <a:avLst/>
           </a:prstGeom>
           <a:solidFill>
-            <a:srgbClr val="10243C"/>
+            <a:srgbClr val="FFFFFF"/>
           </a:solidFill>
           <a:ln>
             <a:solidFill>
@@ -4101,7 +4101,7 @@
             <a:pPr algn="ctr">
               <a:defRPr sz="1200" b="1">
                 <a:solidFill>
-                  <a:srgbClr val="46D6C8"/>
+                  <a:srgbClr val="E6462E"/>
                 </a:solidFill>
               </a:defRPr>
             </a:pPr>
@@ -4116,7 +4116,7 @@
               </a:spcBef>
               <a:defRPr sz="1500">
                 <a:solidFill>
-                  <a:srgbClr val="F4F8FC"/>
+                  <a:srgbClr val="151515"/>
                 </a:solidFill>
               </a:defRPr>
             </a:pPr>
@@ -4141,7 +4141,7 @@
             <a:avLst/>
           </a:prstGeom>
           <a:solidFill>
-            <a:srgbClr val="46D6C8"/>
+            <a:srgbClr val="E6462E"/>
           </a:solidFill>
           <a:ln>
             <a:noFill/>
@@ -4184,7 +4184,7 @@
             <a:avLst/>
           </a:prstGeom>
           <a:solidFill>
-            <a:srgbClr val="10243C"/>
+            <a:srgbClr val="FFFFFF"/>
           </a:solidFill>
           <a:ln>
             <a:solidFill>
@@ -4213,7 +4213,7 @@
             <a:pPr algn="ctr">
               <a:defRPr sz="1200" b="1">
                 <a:solidFill>
-                  <a:srgbClr val="FFBE55"/>
+                  <a:srgbClr val="D39A28"/>
                 </a:solidFill>
               </a:defRPr>
             </a:pPr>
@@ -4228,7 +4228,7 @@
               </a:spcBef>
               <a:defRPr sz="1500">
                 <a:solidFill>
-                  <a:srgbClr val="F4F8FC"/>
+                  <a:srgbClr val="151515"/>
                 </a:solidFill>
               </a:defRPr>
             </a:pPr>
@@ -4253,7 +4253,7 @@
             <a:avLst/>
           </a:prstGeom>
           <a:solidFill>
-            <a:srgbClr val="FFBE55"/>
+            <a:srgbClr val="D39A28"/>
           </a:solidFill>
           <a:ln>
             <a:noFill/>
@@ -4296,7 +4296,7 @@
             <a:avLst/>
           </a:prstGeom>
           <a:solidFill>
-            <a:srgbClr val="10243C"/>
+            <a:srgbClr val="FFFFFF"/>
           </a:solidFill>
           <a:ln>
             <a:solidFill>
@@ -4325,7 +4325,7 @@
             <a:pPr algn="ctr">
               <a:defRPr sz="1200" b="1">
                 <a:solidFill>
-                  <a:srgbClr val="FF6B6B"/>
+                  <a:srgbClr val="A82D23"/>
                 </a:solidFill>
               </a:defRPr>
             </a:pPr>
@@ -4340,7 +4340,7 @@
               </a:spcBef>
               <a:defRPr sz="1500">
                 <a:solidFill>
-                  <a:srgbClr val="F4F8FC"/>
+                  <a:srgbClr val="151515"/>
                 </a:solidFill>
               </a:defRPr>
             </a:pPr>
@@ -4365,7 +4365,7 @@
             <a:avLst/>
           </a:prstGeom>
           <a:solidFill>
-            <a:srgbClr val="FF6B6B"/>
+            <a:srgbClr val="A82D23"/>
           </a:solidFill>
           <a:ln>
             <a:noFill/>
@@ -4408,7 +4408,7 @@
             <a:avLst/>
           </a:prstGeom>
           <a:solidFill>
-            <a:srgbClr val="10243C"/>
+            <a:srgbClr val="FFFFFF"/>
           </a:solidFill>
           <a:ln>
             <a:solidFill>
@@ -4437,7 +4437,7 @@
             <a:pPr algn="ctr">
               <a:defRPr sz="1200" b="1">
                 <a:solidFill>
-                  <a:srgbClr val="46D6C8"/>
+                  <a:srgbClr val="E6462E"/>
                 </a:solidFill>
               </a:defRPr>
             </a:pPr>
@@ -4452,7 +4452,7 @@
               </a:spcBef>
               <a:defRPr sz="1500">
                 <a:solidFill>
-                  <a:srgbClr val="F4F8FC"/>
+                  <a:srgbClr val="151515"/>
                 </a:solidFill>
               </a:defRPr>
             </a:pPr>
@@ -4477,7 +4477,7 @@
             <a:avLst/>
           </a:prstGeom>
           <a:solidFill>
-            <a:srgbClr val="46D6C8"/>
+            <a:srgbClr val="E6462E"/>
           </a:solidFill>
           <a:ln>
             <a:noFill/>
@@ -4520,7 +4520,7 @@
             <a:avLst/>
           </a:prstGeom>
           <a:solidFill>
-            <a:srgbClr val="10243C"/>
+            <a:srgbClr val="FFFFFF"/>
           </a:solidFill>
           <a:ln>
             <a:solidFill>
@@ -4549,7 +4549,7 @@
             <a:pPr algn="ctr">
               <a:defRPr sz="1200" b="1">
                 <a:solidFill>
-                  <a:srgbClr val="FFBE55"/>
+                  <a:srgbClr val="D39A28"/>
                 </a:solidFill>
               </a:defRPr>
             </a:pPr>
@@ -4564,7 +4564,7 @@
               </a:spcBef>
               <a:defRPr sz="1500">
                 <a:solidFill>
-                  <a:srgbClr val="F4F8FC"/>
+                  <a:srgbClr val="151515"/>
                 </a:solidFill>
               </a:defRPr>
             </a:pPr>
@@ -4589,7 +4589,7 @@
             <a:avLst/>
           </a:prstGeom>
           <a:solidFill>
-            <a:srgbClr val="FFBE55"/>
+            <a:srgbClr val="D39A28"/>
           </a:solidFill>
           <a:ln>
             <a:noFill/>
@@ -4632,7 +4632,7 @@
             <a:avLst/>
           </a:prstGeom>
           <a:solidFill>
-            <a:srgbClr val="10243C"/>
+            <a:srgbClr val="FFFFFF"/>
           </a:solidFill>
           <a:ln>
             <a:solidFill>
@@ -4661,7 +4661,7 @@
             <a:pPr algn="ctr">
               <a:defRPr sz="1200" b="1">
                 <a:solidFill>
-                  <a:srgbClr val="FF6B6B"/>
+                  <a:srgbClr val="A82D23"/>
                 </a:solidFill>
               </a:defRPr>
             </a:pPr>
@@ -4676,7 +4676,7 @@
               </a:spcBef>
               <a:defRPr sz="1500">
                 <a:solidFill>
-                  <a:srgbClr val="F4F8FC"/>
+                  <a:srgbClr val="151515"/>
                 </a:solidFill>
               </a:defRPr>
             </a:pPr>
@@ -4701,7 +4701,7 @@
             <a:avLst/>
           </a:prstGeom>
           <a:solidFill>
-            <a:srgbClr val="FF6B6B"/>
+            <a:srgbClr val="A82D23"/>
           </a:solidFill>
           <a:ln>
             <a:noFill/>
@@ -4754,7 +4754,7 @@
             <a:pPr>
               <a:defRPr sz="900">
                 <a:solidFill>
-                  <a:srgbClr val="9AB2C8"/>
+                  <a:srgbClr val="62666A"/>
                 </a:solidFill>
               </a:defRPr>
             </a:pPr>
@@ -4778,7 +4778,7 @@
     <p:bg>
       <p:bgPr>
         <a:solidFill>
-          <a:srgbClr val="07111F"/>
+          <a:srgbClr val="F4F1E8"/>
         </a:solidFill>
         <a:effectLst/>
       </p:bgPr>
@@ -4805,7 +4805,7 @@
             <a:avLst/>
           </a:prstGeom>
           <a:solidFill>
-            <a:srgbClr val="46D6C8"/>
+            <a:srgbClr val="E6462E"/>
           </a:solidFill>
           <a:ln>
             <a:noFill/>
@@ -4858,7 +4858,7 @@
             <a:pPr>
               <a:defRPr sz="900" b="1">
                 <a:solidFill>
-                  <a:srgbClr val="46D6C8"/>
+                  <a:srgbClr val="E6462E"/>
                 </a:solidFill>
               </a:defRPr>
             </a:pPr>
@@ -4893,7 +4893,7 @@
             <a:pPr algn="l">
               <a:defRPr sz="2700" b="1">
                 <a:solidFill>
-                  <a:srgbClr val="F4F8FC"/>
+                  <a:srgbClr val="151515"/>
                 </a:solidFill>
               </a:defRPr>
             </a:pPr>
@@ -4918,7 +4918,7 @@
             <a:avLst/>
           </a:prstGeom>
           <a:solidFill>
-            <a:srgbClr val="10243C"/>
+            <a:srgbClr val="FFFFFF"/>
           </a:solidFill>
           <a:ln>
             <a:solidFill>
@@ -4947,7 +4947,7 @@
             <a:pPr algn="ctr">
               <a:defRPr sz="1200" b="1">
                 <a:solidFill>
-                  <a:srgbClr val="46D6C8"/>
+                  <a:srgbClr val="E6462E"/>
                 </a:solidFill>
               </a:defRPr>
             </a:pPr>
@@ -4962,7 +4962,7 @@
               </a:spcBef>
               <a:defRPr sz="1100">
                 <a:solidFill>
-                  <a:srgbClr val="F4F8FC"/>
+                  <a:srgbClr val="151515"/>
                 </a:solidFill>
               </a:defRPr>
             </a:pPr>
@@ -4987,7 +4987,7 @@
             <a:avLst/>
           </a:prstGeom>
           <a:solidFill>
-            <a:srgbClr val="46D6C8"/>
+            <a:srgbClr val="E6462E"/>
           </a:solidFill>
           <a:ln>
             <a:noFill/>
@@ -5030,7 +5030,7 @@
             <a:avLst/>
           </a:prstGeom>
           <a:solidFill>
-            <a:srgbClr val="10243C"/>
+            <a:srgbClr val="FFFFFF"/>
           </a:solidFill>
           <a:ln>
             <a:solidFill>
@@ -5059,7 +5059,7 @@
             <a:pPr algn="ctr">
               <a:defRPr sz="1200" b="1">
                 <a:solidFill>
-                  <a:srgbClr val="55A7FF"/>
+                  <a:srgbClr val="176B87"/>
                 </a:solidFill>
               </a:defRPr>
             </a:pPr>
@@ -5074,7 +5074,7 @@
               </a:spcBef>
               <a:defRPr sz="1100">
                 <a:solidFill>
-                  <a:srgbClr val="F4F8FC"/>
+                  <a:srgbClr val="151515"/>
                 </a:solidFill>
               </a:defRPr>
             </a:pPr>
@@ -5099,7 +5099,7 @@
             <a:avLst/>
           </a:prstGeom>
           <a:solidFill>
-            <a:srgbClr val="55A7FF"/>
+            <a:srgbClr val="176B87"/>
           </a:solidFill>
           <a:ln>
             <a:noFill/>
@@ -5142,7 +5142,7 @@
             <a:avLst/>
           </a:prstGeom>
           <a:solidFill>
-            <a:srgbClr val="10243C"/>
+            <a:srgbClr val="FFFFFF"/>
           </a:solidFill>
           <a:ln>
             <a:solidFill>
@@ -5171,7 +5171,7 @@
             <a:pPr algn="ctr">
               <a:defRPr sz="1200" b="1">
                 <a:solidFill>
-                  <a:srgbClr val="FFBE55"/>
+                  <a:srgbClr val="D39A28"/>
                 </a:solidFill>
               </a:defRPr>
             </a:pPr>
@@ -5186,7 +5186,7 @@
               </a:spcBef>
               <a:defRPr sz="1100">
                 <a:solidFill>
-                  <a:srgbClr val="F4F8FC"/>
+                  <a:srgbClr val="151515"/>
                 </a:solidFill>
               </a:defRPr>
             </a:pPr>
@@ -5211,7 +5211,7 @@
             <a:avLst/>
           </a:prstGeom>
           <a:solidFill>
-            <a:srgbClr val="FFBE55"/>
+            <a:srgbClr val="D39A28"/>
           </a:solidFill>
           <a:ln>
             <a:noFill/>
@@ -5254,7 +5254,7 @@
             <a:avLst/>
           </a:prstGeom>
           <a:solidFill>
-            <a:srgbClr val="10243C"/>
+            <a:srgbClr val="FFFFFF"/>
           </a:solidFill>
           <a:ln>
             <a:solidFill>
@@ -5283,7 +5283,7 @@
             <a:pPr algn="ctr">
               <a:defRPr sz="1200" b="1">
                 <a:solidFill>
-                  <a:srgbClr val="46D6C8"/>
+                  <a:srgbClr val="E6462E"/>
                 </a:solidFill>
               </a:defRPr>
             </a:pPr>
@@ -5298,7 +5298,7 @@
               </a:spcBef>
               <a:defRPr sz="1100">
                 <a:solidFill>
-                  <a:srgbClr val="F4F8FC"/>
+                  <a:srgbClr val="151515"/>
                 </a:solidFill>
               </a:defRPr>
             </a:pPr>
@@ -5323,7 +5323,7 @@
             <a:avLst/>
           </a:prstGeom>
           <a:solidFill>
-            <a:srgbClr val="46D6C8"/>
+            <a:srgbClr val="E6462E"/>
           </a:solidFill>
           <a:ln>
             <a:noFill/>
@@ -5376,7 +5376,7 @@
             <a:pPr>
               <a:defRPr sz="900">
                 <a:solidFill>
-                  <a:srgbClr val="9AB2C8"/>
+                  <a:srgbClr val="62666A"/>
                 </a:solidFill>
               </a:defRPr>
             </a:pPr>
@@ -5400,7 +5400,7 @@
     <p:bg>
       <p:bgPr>
         <a:solidFill>
-          <a:srgbClr val="07111F"/>
+          <a:srgbClr val="F4F1E8"/>
         </a:solidFill>
         <a:effectLst/>
       </p:bgPr>
@@ -5427,7 +5427,7 @@
             <a:avLst/>
           </a:prstGeom>
           <a:solidFill>
-            <a:srgbClr val="46D6C8"/>
+            <a:srgbClr val="E6462E"/>
           </a:solidFill>
           <a:ln>
             <a:noFill/>
@@ -5480,7 +5480,7 @@
             <a:pPr>
               <a:defRPr sz="900" b="1">
                 <a:solidFill>
-                  <a:srgbClr val="46D6C8"/>
+                  <a:srgbClr val="E6462E"/>
                 </a:solidFill>
               </a:defRPr>
             </a:pPr>
@@ -5515,7 +5515,7 @@
             <a:pPr algn="l">
               <a:defRPr sz="2700" b="1">
                 <a:solidFill>
-                  <a:srgbClr val="F4F8FC"/>
+                  <a:srgbClr val="151515"/>
                 </a:solidFill>
               </a:defRPr>
             </a:pPr>
@@ -5540,7 +5540,7 @@
             <a:avLst/>
           </a:prstGeom>
           <a:solidFill>
-            <a:srgbClr val="10243C"/>
+            <a:srgbClr val="FFFFFF"/>
           </a:solidFill>
           <a:ln>
             <a:solidFill>
@@ -5569,7 +5569,7 @@
             <a:pPr algn="ctr">
               <a:defRPr sz="1200" b="1">
                 <a:solidFill>
-                  <a:srgbClr val="46D6C8"/>
+                  <a:srgbClr val="E6462E"/>
                 </a:solidFill>
               </a:defRPr>
             </a:pPr>
@@ -5584,7 +5584,7 @@
               </a:spcBef>
               <a:defRPr sz="1500">
                 <a:solidFill>
-                  <a:srgbClr val="F4F8FC"/>
+                  <a:srgbClr val="151515"/>
                 </a:solidFill>
               </a:defRPr>
             </a:pPr>
@@ -5609,7 +5609,7 @@
             <a:avLst/>
           </a:prstGeom>
           <a:solidFill>
-            <a:srgbClr val="46D6C8"/>
+            <a:srgbClr val="E6462E"/>
           </a:solidFill>
           <a:ln>
             <a:noFill/>
@@ -5652,7 +5652,7 @@
             <a:avLst/>
           </a:prstGeom>
           <a:solidFill>
-            <a:srgbClr val="10243C"/>
+            <a:srgbClr val="FFFFFF"/>
           </a:solidFill>
           <a:ln>
             <a:solidFill>
@@ -5681,7 +5681,7 @@
             <a:pPr algn="ctr">
               <a:defRPr sz="1200" b="1">
                 <a:solidFill>
-                  <a:srgbClr val="55A7FF"/>
+                  <a:srgbClr val="176B87"/>
                 </a:solidFill>
               </a:defRPr>
             </a:pPr>
@@ -5696,7 +5696,7 @@
               </a:spcBef>
               <a:defRPr sz="1500">
                 <a:solidFill>
-                  <a:srgbClr val="F4F8FC"/>
+                  <a:srgbClr val="151515"/>
                 </a:solidFill>
               </a:defRPr>
             </a:pPr>
@@ -5721,7 +5721,7 @@
             <a:avLst/>
           </a:prstGeom>
           <a:solidFill>
-            <a:srgbClr val="55A7FF"/>
+            <a:srgbClr val="176B87"/>
           </a:solidFill>
           <a:ln>
             <a:noFill/>
@@ -5764,7 +5764,7 @@
             <a:avLst/>
           </a:prstGeom>
           <a:solidFill>
-            <a:srgbClr val="10243C"/>
+            <a:srgbClr val="FFFFFF"/>
           </a:solidFill>
           <a:ln>
             <a:solidFill>
@@ -5793,7 +5793,7 @@
             <a:pPr algn="ctr">
               <a:defRPr sz="1200" b="1">
                 <a:solidFill>
-                  <a:srgbClr val="FFBE55"/>
+                  <a:srgbClr val="D39A28"/>
                 </a:solidFill>
               </a:defRPr>
             </a:pPr>
@@ -5808,7 +5808,7 @@
               </a:spcBef>
               <a:defRPr sz="1500">
                 <a:solidFill>
-                  <a:srgbClr val="F4F8FC"/>
+                  <a:srgbClr val="151515"/>
                 </a:solidFill>
               </a:defRPr>
             </a:pPr>
@@ -5833,7 +5833,7 @@
             <a:avLst/>
           </a:prstGeom>
           <a:solidFill>
-            <a:srgbClr val="FFBE55"/>
+            <a:srgbClr val="D39A28"/>
           </a:solidFill>
           <a:ln>
             <a:noFill/>
@@ -5876,7 +5876,7 @@
             <a:avLst/>
           </a:prstGeom>
           <a:solidFill>
-            <a:srgbClr val="10243C"/>
+            <a:srgbClr val="FFFFFF"/>
           </a:solidFill>
           <a:ln>
             <a:solidFill>
@@ -5905,7 +5905,7 @@
             <a:pPr algn="ctr">
               <a:defRPr sz="1200" b="1">
                 <a:solidFill>
-                  <a:srgbClr val="46D6C8"/>
+                  <a:srgbClr val="E6462E"/>
                 </a:solidFill>
               </a:defRPr>
             </a:pPr>
@@ -5920,7 +5920,7 @@
               </a:spcBef>
               <a:defRPr sz="1500">
                 <a:solidFill>
-                  <a:srgbClr val="F4F8FC"/>
+                  <a:srgbClr val="151515"/>
                 </a:solidFill>
               </a:defRPr>
             </a:pPr>
@@ -5945,7 +5945,7 @@
             <a:avLst/>
           </a:prstGeom>
           <a:solidFill>
-            <a:srgbClr val="46D6C8"/>
+            <a:srgbClr val="E6462E"/>
           </a:solidFill>
           <a:ln>
             <a:noFill/>
@@ -5988,7 +5988,7 @@
             <a:avLst/>
           </a:prstGeom>
           <a:solidFill>
-            <a:srgbClr val="10243C"/>
+            <a:srgbClr val="FFFFFF"/>
           </a:solidFill>
           <a:ln>
             <a:solidFill>
@@ -6017,7 +6017,7 @@
             <a:pPr algn="ctr">
               <a:defRPr sz="1200" b="1">
                 <a:solidFill>
-                  <a:srgbClr val="55A7FF"/>
+                  <a:srgbClr val="176B87"/>
                 </a:solidFill>
               </a:defRPr>
             </a:pPr>
@@ -6032,7 +6032,7 @@
               </a:spcBef>
               <a:defRPr sz="1500">
                 <a:solidFill>
-                  <a:srgbClr val="F4F8FC"/>
+                  <a:srgbClr val="151515"/>
                 </a:solidFill>
               </a:defRPr>
             </a:pPr>
@@ -6057,7 +6057,7 @@
             <a:avLst/>
           </a:prstGeom>
           <a:solidFill>
-            <a:srgbClr val="55A7FF"/>
+            <a:srgbClr val="176B87"/>
           </a:solidFill>
           <a:ln>
             <a:noFill/>
@@ -6100,7 +6100,7 @@
             <a:avLst/>
           </a:prstGeom>
           <a:solidFill>
-            <a:srgbClr val="10243C"/>
+            <a:srgbClr val="FFFFFF"/>
           </a:solidFill>
           <a:ln>
             <a:solidFill>
@@ -6129,7 +6129,7 @@
             <a:pPr algn="ctr">
               <a:defRPr sz="1200" b="1">
                 <a:solidFill>
-                  <a:srgbClr val="FFBE55"/>
+                  <a:srgbClr val="D39A28"/>
                 </a:solidFill>
               </a:defRPr>
             </a:pPr>
@@ -6144,7 +6144,7 @@
               </a:spcBef>
               <a:defRPr sz="1500">
                 <a:solidFill>
-                  <a:srgbClr val="F4F8FC"/>
+                  <a:srgbClr val="151515"/>
                 </a:solidFill>
               </a:defRPr>
             </a:pPr>
@@ -6169,7 +6169,7 @@
             <a:avLst/>
           </a:prstGeom>
           <a:solidFill>
-            <a:srgbClr val="FFBE55"/>
+            <a:srgbClr val="D39A28"/>
           </a:solidFill>
           <a:ln>
             <a:noFill/>
@@ -6222,7 +6222,7 @@
             <a:pPr>
               <a:defRPr sz="900">
                 <a:solidFill>
-                  <a:srgbClr val="9AB2C8"/>
+                  <a:srgbClr val="62666A"/>
                 </a:solidFill>
               </a:defRPr>
             </a:pPr>
@@ -6246,7 +6246,7 @@
     <p:bg>
       <p:bgPr>
         <a:solidFill>
-          <a:srgbClr val="07111F"/>
+          <a:srgbClr val="F4F1E8"/>
         </a:solidFill>
         <a:effectLst/>
       </p:bgPr>
@@ -6273,7 +6273,7 @@
             <a:avLst/>
           </a:prstGeom>
           <a:solidFill>
-            <a:srgbClr val="46D6C8"/>
+            <a:srgbClr val="E6462E"/>
           </a:solidFill>
           <a:ln>
             <a:noFill/>
@@ -6326,7 +6326,7 @@
             <a:pPr>
               <a:defRPr sz="900" b="1">
                 <a:solidFill>
-                  <a:srgbClr val="46D6C8"/>
+                  <a:srgbClr val="E6462E"/>
                 </a:solidFill>
               </a:defRPr>
             </a:pPr>
@@ -6361,7 +6361,7 @@
             <a:pPr algn="l">
               <a:defRPr sz="2700" b="1">
                 <a:solidFill>
-                  <a:srgbClr val="F4F8FC"/>
+                  <a:srgbClr val="151515"/>
                 </a:solidFill>
               </a:defRPr>
             </a:pPr>
@@ -6386,7 +6386,7 @@
             <a:avLst/>
           </a:prstGeom>
           <a:solidFill>
-            <a:srgbClr val="10243C"/>
+            <a:srgbClr val="FFFFFF"/>
           </a:solidFill>
           <a:ln>
             <a:solidFill>
@@ -6415,7 +6415,7 @@
             <a:pPr algn="ctr">
               <a:defRPr sz="1200" b="1">
                 <a:solidFill>
-                  <a:srgbClr val="46D6C8"/>
+                  <a:srgbClr val="E6462E"/>
                 </a:solidFill>
               </a:defRPr>
             </a:pPr>
@@ -6430,7 +6430,7 @@
               </a:spcBef>
               <a:defRPr sz="1500">
                 <a:solidFill>
-                  <a:srgbClr val="F4F8FC"/>
+                  <a:srgbClr val="151515"/>
                 </a:solidFill>
               </a:defRPr>
             </a:pPr>
@@ -6455,7 +6455,7 @@
             <a:avLst/>
           </a:prstGeom>
           <a:solidFill>
-            <a:srgbClr val="46D6C8"/>
+            <a:srgbClr val="E6462E"/>
           </a:solidFill>
           <a:ln>
             <a:noFill/>
@@ -6498,7 +6498,7 @@
             <a:avLst/>
           </a:prstGeom>
           <a:solidFill>
-            <a:srgbClr val="10243C"/>
+            <a:srgbClr val="FFFFFF"/>
           </a:solidFill>
           <a:ln>
             <a:solidFill>
@@ -6527,7 +6527,7 @@
             <a:pPr algn="ctr">
               <a:defRPr sz="1200" b="1">
                 <a:solidFill>
-                  <a:srgbClr val="55A7FF"/>
+                  <a:srgbClr val="176B87"/>
                 </a:solidFill>
               </a:defRPr>
             </a:pPr>
@@ -6542,7 +6542,7 @@
               </a:spcBef>
               <a:defRPr sz="1500">
                 <a:solidFill>
-                  <a:srgbClr val="F4F8FC"/>
+                  <a:srgbClr val="151515"/>
                 </a:solidFill>
               </a:defRPr>
             </a:pPr>
@@ -6567,7 +6567,7 @@
             <a:avLst/>
           </a:prstGeom>
           <a:solidFill>
-            <a:srgbClr val="55A7FF"/>
+            <a:srgbClr val="176B87"/>
           </a:solidFill>
           <a:ln>
             <a:noFill/>
@@ -6610,7 +6610,7 @@
             <a:avLst/>
           </a:prstGeom>
           <a:solidFill>
-            <a:srgbClr val="10243C"/>
+            <a:srgbClr val="FFFFFF"/>
           </a:solidFill>
           <a:ln>
             <a:solidFill>
@@ -6639,7 +6639,7 @@
             <a:pPr algn="ctr">
               <a:defRPr sz="1200" b="1">
                 <a:solidFill>
-                  <a:srgbClr val="FFBE55"/>
+                  <a:srgbClr val="D39A28"/>
                 </a:solidFill>
               </a:defRPr>
             </a:pPr>
@@ -6654,7 +6654,7 @@
               </a:spcBef>
               <a:defRPr sz="1500">
                 <a:solidFill>
-                  <a:srgbClr val="F4F8FC"/>
+                  <a:srgbClr val="151515"/>
                 </a:solidFill>
               </a:defRPr>
             </a:pPr>
@@ -6679,7 +6679,7 @@
             <a:avLst/>
           </a:prstGeom>
           <a:solidFill>
-            <a:srgbClr val="FFBE55"/>
+            <a:srgbClr val="D39A28"/>
           </a:solidFill>
           <a:ln>
             <a:noFill/>
@@ -6722,7 +6722,7 @@
             <a:avLst/>
           </a:prstGeom>
           <a:solidFill>
-            <a:srgbClr val="10243C"/>
+            <a:srgbClr val="FFFFFF"/>
           </a:solidFill>
           <a:ln>
             <a:solidFill>
@@ -6751,7 +6751,7 @@
             <a:pPr algn="ctr">
               <a:defRPr sz="1200" b="1">
                 <a:solidFill>
-                  <a:srgbClr val="46D6C8"/>
+                  <a:srgbClr val="E6462E"/>
                 </a:solidFill>
               </a:defRPr>
             </a:pPr>
@@ -6766,7 +6766,7 @@
               </a:spcBef>
               <a:defRPr sz="1500">
                 <a:solidFill>
-                  <a:srgbClr val="F4F8FC"/>
+                  <a:srgbClr val="151515"/>
                 </a:solidFill>
               </a:defRPr>
             </a:pPr>
@@ -6791,7 +6791,7 @@
             <a:avLst/>
           </a:prstGeom>
           <a:solidFill>
-            <a:srgbClr val="46D6C8"/>
+            <a:srgbClr val="E6462E"/>
           </a:solidFill>
           <a:ln>
             <a:noFill/>
@@ -6834,7 +6834,7 @@
             <a:avLst/>
           </a:prstGeom>
           <a:solidFill>
-            <a:srgbClr val="10243C"/>
+            <a:srgbClr val="FFFFFF"/>
           </a:solidFill>
           <a:ln>
             <a:solidFill>
@@ -6863,7 +6863,7 @@
             <a:pPr algn="ctr">
               <a:defRPr sz="1200" b="1">
                 <a:solidFill>
-                  <a:srgbClr val="55A7FF"/>
+                  <a:srgbClr val="176B87"/>
                 </a:solidFill>
               </a:defRPr>
             </a:pPr>
@@ -6878,7 +6878,7 @@
               </a:spcBef>
               <a:defRPr sz="1500">
                 <a:solidFill>
-                  <a:srgbClr val="F4F8FC"/>
+                  <a:srgbClr val="151515"/>
                 </a:solidFill>
               </a:defRPr>
             </a:pPr>
@@ -6903,7 +6903,7 @@
             <a:avLst/>
           </a:prstGeom>
           <a:solidFill>
-            <a:srgbClr val="55A7FF"/>
+            <a:srgbClr val="176B87"/>
           </a:solidFill>
           <a:ln>
             <a:noFill/>
@@ -6946,7 +6946,7 @@
             <a:avLst/>
           </a:prstGeom>
           <a:solidFill>
-            <a:srgbClr val="10243C"/>
+            <a:srgbClr val="FFFFFF"/>
           </a:solidFill>
           <a:ln>
             <a:solidFill>
@@ -6975,7 +6975,7 @@
             <a:pPr algn="ctr">
               <a:defRPr sz="1200" b="1">
                 <a:solidFill>
-                  <a:srgbClr val="FFBE55"/>
+                  <a:srgbClr val="D39A28"/>
                 </a:solidFill>
               </a:defRPr>
             </a:pPr>
@@ -6990,7 +6990,7 @@
               </a:spcBef>
               <a:defRPr sz="1500">
                 <a:solidFill>
-                  <a:srgbClr val="F4F8FC"/>
+                  <a:srgbClr val="151515"/>
                 </a:solidFill>
               </a:defRPr>
             </a:pPr>
@@ -7015,7 +7015,7 @@
             <a:avLst/>
           </a:prstGeom>
           <a:solidFill>
-            <a:srgbClr val="FFBE55"/>
+            <a:srgbClr val="D39A28"/>
           </a:solidFill>
           <a:ln>
             <a:noFill/>
@@ -7068,7 +7068,7 @@
             <a:pPr>
               <a:defRPr sz="900">
                 <a:solidFill>
-                  <a:srgbClr val="9AB2C8"/>
+                  <a:srgbClr val="62666A"/>
                 </a:solidFill>
               </a:defRPr>
             </a:pPr>
@@ -7092,7 +7092,7 @@
     <p:bg>
       <p:bgPr>
         <a:solidFill>
-          <a:srgbClr val="07111F"/>
+          <a:srgbClr val="F4F1E8"/>
         </a:solidFill>
         <a:effectLst/>
       </p:bgPr>
@@ -7119,7 +7119,7 @@
             <a:avLst/>
           </a:prstGeom>
           <a:solidFill>
-            <a:srgbClr val="46D6C8"/>
+            <a:srgbClr val="E6462E"/>
           </a:solidFill>
           <a:ln>
             <a:noFill/>
@@ -7172,7 +7172,7 @@
             <a:pPr>
               <a:defRPr sz="900" b="1">
                 <a:solidFill>
-                  <a:srgbClr val="46D6C8"/>
+                  <a:srgbClr val="E6462E"/>
                 </a:solidFill>
               </a:defRPr>
             </a:pPr>
@@ -7207,7 +7207,7 @@
             <a:pPr algn="l">
               <a:defRPr sz="2700" b="1">
                 <a:solidFill>
-                  <a:srgbClr val="F4F8FC"/>
+                  <a:srgbClr val="151515"/>
                 </a:solidFill>
               </a:defRPr>
             </a:pPr>
@@ -7232,7 +7232,7 @@
             <a:avLst/>
           </a:prstGeom>
           <a:solidFill>
-            <a:srgbClr val="10243C"/>
+            <a:srgbClr val="FFFFFF"/>
           </a:solidFill>
           <a:ln>
             <a:solidFill>
@@ -7261,7 +7261,7 @@
             <a:pPr algn="ctr">
               <a:defRPr sz="1200" b="1">
                 <a:solidFill>
-                  <a:srgbClr val="46D6C8"/>
+                  <a:srgbClr val="E6462E"/>
                 </a:solidFill>
               </a:defRPr>
             </a:pPr>
@@ -7276,7 +7276,7 @@
               </a:spcBef>
               <a:defRPr sz="1500">
                 <a:solidFill>
-                  <a:srgbClr val="F4F8FC"/>
+                  <a:srgbClr val="151515"/>
                 </a:solidFill>
               </a:defRPr>
             </a:pPr>
@@ -7301,7 +7301,7 @@
             <a:avLst/>
           </a:prstGeom>
           <a:solidFill>
-            <a:srgbClr val="46D6C8"/>
+            <a:srgbClr val="E6462E"/>
           </a:solidFill>
           <a:ln>
             <a:noFill/>
@@ -7344,7 +7344,7 @@
             <a:avLst/>
           </a:prstGeom>
           <a:solidFill>
-            <a:srgbClr val="10243C"/>
+            <a:srgbClr val="FFFFFF"/>
           </a:solidFill>
           <a:ln>
             <a:solidFill>
@@ -7373,7 +7373,7 @@
             <a:pPr algn="ctr">
               <a:defRPr sz="1200" b="1">
                 <a:solidFill>
-                  <a:srgbClr val="55A7FF"/>
+                  <a:srgbClr val="176B87"/>
                 </a:solidFill>
               </a:defRPr>
             </a:pPr>
@@ -7388,7 +7388,7 @@
               </a:spcBef>
               <a:defRPr sz="1500">
                 <a:solidFill>
-                  <a:srgbClr val="F4F8FC"/>
+                  <a:srgbClr val="151515"/>
                 </a:solidFill>
               </a:defRPr>
             </a:pPr>
@@ -7413,7 +7413,7 @@
             <a:avLst/>
           </a:prstGeom>
           <a:solidFill>
-            <a:srgbClr val="55A7FF"/>
+            <a:srgbClr val="176B87"/>
           </a:solidFill>
           <a:ln>
             <a:noFill/>
@@ -7456,7 +7456,7 @@
             <a:avLst/>
           </a:prstGeom>
           <a:solidFill>
-            <a:srgbClr val="10243C"/>
+            <a:srgbClr val="FFFFFF"/>
           </a:solidFill>
           <a:ln>
             <a:solidFill>
@@ -7485,7 +7485,7 @@
             <a:pPr algn="ctr">
               <a:defRPr sz="1200" b="1">
                 <a:solidFill>
-                  <a:srgbClr val="FFBE55"/>
+                  <a:srgbClr val="D39A28"/>
                 </a:solidFill>
               </a:defRPr>
             </a:pPr>
@@ -7500,7 +7500,7 @@
               </a:spcBef>
               <a:defRPr sz="1500">
                 <a:solidFill>
-                  <a:srgbClr val="F4F8FC"/>
+                  <a:srgbClr val="151515"/>
                 </a:solidFill>
               </a:defRPr>
             </a:pPr>
@@ -7525,7 +7525,7 @@
             <a:avLst/>
           </a:prstGeom>
           <a:solidFill>
-            <a:srgbClr val="FFBE55"/>
+            <a:srgbClr val="D39A28"/>
           </a:solidFill>
           <a:ln>
             <a:noFill/>
@@ -7568,7 +7568,7 @@
             <a:avLst/>
           </a:prstGeom>
           <a:solidFill>
-            <a:srgbClr val="10243C"/>
+            <a:srgbClr val="FFFFFF"/>
           </a:solidFill>
           <a:ln>
             <a:solidFill>
@@ -7597,7 +7597,7 @@
             <a:pPr algn="ctr">
               <a:defRPr sz="1200" b="1">
                 <a:solidFill>
-                  <a:srgbClr val="46D6C8"/>
+                  <a:srgbClr val="E6462E"/>
                 </a:solidFill>
               </a:defRPr>
             </a:pPr>
@@ -7612,7 +7612,7 @@
               </a:spcBef>
               <a:defRPr sz="1500">
                 <a:solidFill>
-                  <a:srgbClr val="F4F8FC"/>
+                  <a:srgbClr val="151515"/>
                 </a:solidFill>
               </a:defRPr>
             </a:pPr>
@@ -7637,7 +7637,7 @@
             <a:avLst/>
           </a:prstGeom>
           <a:solidFill>
-            <a:srgbClr val="46D6C8"/>
+            <a:srgbClr val="E6462E"/>
           </a:solidFill>
           <a:ln>
             <a:noFill/>
@@ -7680,7 +7680,7 @@
             <a:avLst/>
           </a:prstGeom>
           <a:solidFill>
-            <a:srgbClr val="10243C"/>
+            <a:srgbClr val="FFFFFF"/>
           </a:solidFill>
           <a:ln>
             <a:solidFill>
@@ -7709,7 +7709,7 @@
             <a:pPr algn="ctr">
               <a:defRPr sz="1200" b="1">
                 <a:solidFill>
-                  <a:srgbClr val="55A7FF"/>
+                  <a:srgbClr val="176B87"/>
                 </a:solidFill>
               </a:defRPr>
             </a:pPr>
@@ -7724,7 +7724,7 @@
               </a:spcBef>
               <a:defRPr sz="1500">
                 <a:solidFill>
-                  <a:srgbClr val="F4F8FC"/>
+                  <a:srgbClr val="151515"/>
                 </a:solidFill>
               </a:defRPr>
             </a:pPr>
@@ -7749,7 +7749,7 @@
             <a:avLst/>
           </a:prstGeom>
           <a:solidFill>
-            <a:srgbClr val="55A7FF"/>
+            <a:srgbClr val="176B87"/>
           </a:solidFill>
           <a:ln>
             <a:noFill/>
@@ -7792,7 +7792,7 @@
             <a:avLst/>
           </a:prstGeom>
           <a:solidFill>
-            <a:srgbClr val="10243C"/>
+            <a:srgbClr val="FFFFFF"/>
           </a:solidFill>
           <a:ln>
             <a:solidFill>
@@ -7821,7 +7821,7 @@
             <a:pPr algn="ctr">
               <a:defRPr sz="1200" b="1">
                 <a:solidFill>
-                  <a:srgbClr val="FFBE55"/>
+                  <a:srgbClr val="D39A28"/>
                 </a:solidFill>
               </a:defRPr>
             </a:pPr>
@@ -7836,7 +7836,7 @@
               </a:spcBef>
               <a:defRPr sz="1500">
                 <a:solidFill>
-                  <a:srgbClr val="F4F8FC"/>
+                  <a:srgbClr val="151515"/>
                 </a:solidFill>
               </a:defRPr>
             </a:pPr>
@@ -7861,7 +7861,7 @@
             <a:avLst/>
           </a:prstGeom>
           <a:solidFill>
-            <a:srgbClr val="FFBE55"/>
+            <a:srgbClr val="D39A28"/>
           </a:solidFill>
           <a:ln>
             <a:noFill/>
@@ -7914,7 +7914,7 @@
             <a:pPr>
               <a:defRPr sz="900">
                 <a:solidFill>
-                  <a:srgbClr val="9AB2C8"/>
+                  <a:srgbClr val="62666A"/>
                 </a:solidFill>
               </a:defRPr>
             </a:pPr>
@@ -7938,7 +7938,7 @@
     <p:bg>
       <p:bgPr>
         <a:solidFill>
-          <a:srgbClr val="07111F"/>
+          <a:srgbClr val="F4F1E8"/>
         </a:solidFill>
         <a:effectLst/>
       </p:bgPr>
@@ -7965,7 +7965,7 @@
             <a:avLst/>
           </a:prstGeom>
           <a:solidFill>
-            <a:srgbClr val="46D6C8"/>
+            <a:srgbClr val="E6462E"/>
           </a:solidFill>
           <a:ln>
             <a:noFill/>
@@ -8018,7 +8018,7 @@
             <a:pPr>
               <a:defRPr sz="900" b="1">
                 <a:solidFill>
-                  <a:srgbClr val="46D6C8"/>
+                  <a:srgbClr val="E6462E"/>
                 </a:solidFill>
               </a:defRPr>
             </a:pPr>
@@ -8053,7 +8053,7 @@
             <a:pPr algn="l">
               <a:defRPr sz="2700" b="1">
                 <a:solidFill>
-                  <a:srgbClr val="F4F8FC"/>
+                  <a:srgbClr val="151515"/>
                 </a:solidFill>
               </a:defRPr>
             </a:pPr>
@@ -8078,7 +8078,7 @@
             <a:avLst/>
           </a:prstGeom>
           <a:solidFill>
-            <a:srgbClr val="10243C"/>
+            <a:srgbClr val="FFFFFF"/>
           </a:solidFill>
           <a:ln>
             <a:solidFill>
@@ -8107,7 +8107,7 @@
             <a:pPr algn="ctr">
               <a:defRPr sz="1200" b="1">
                 <a:solidFill>
-                  <a:srgbClr val="46D6C8"/>
+                  <a:srgbClr val="E6462E"/>
                 </a:solidFill>
               </a:defRPr>
             </a:pPr>
@@ -8122,7 +8122,7 @@
               </a:spcBef>
               <a:defRPr sz="1500">
                 <a:solidFill>
-                  <a:srgbClr val="F4F8FC"/>
+                  <a:srgbClr val="151515"/>
                 </a:solidFill>
               </a:defRPr>
             </a:pPr>
@@ -8147,7 +8147,7 @@
             <a:avLst/>
           </a:prstGeom>
           <a:solidFill>
-            <a:srgbClr val="46D6C8"/>
+            <a:srgbClr val="E6462E"/>
           </a:solidFill>
           <a:ln>
             <a:noFill/>
@@ -8190,7 +8190,7 @@
             <a:avLst/>
           </a:prstGeom>
           <a:solidFill>
-            <a:srgbClr val="10243C"/>
+            <a:srgbClr val="FFFFFF"/>
           </a:solidFill>
           <a:ln>
             <a:solidFill>
@@ -8219,7 +8219,7 @@
             <a:pPr algn="ctr">
               <a:defRPr sz="1200" b="1">
                 <a:solidFill>
-                  <a:srgbClr val="55A7FF"/>
+                  <a:srgbClr val="176B87"/>
                 </a:solidFill>
               </a:defRPr>
             </a:pPr>
@@ -8234,7 +8234,7 @@
               </a:spcBef>
               <a:defRPr sz="1500">
                 <a:solidFill>
-                  <a:srgbClr val="F4F8FC"/>
+                  <a:srgbClr val="151515"/>
                 </a:solidFill>
               </a:defRPr>
             </a:pPr>
@@ -8259,7 +8259,7 @@
             <a:avLst/>
           </a:prstGeom>
           <a:solidFill>
-            <a:srgbClr val="55A7FF"/>
+            <a:srgbClr val="176B87"/>
           </a:solidFill>
           <a:ln>
             <a:noFill/>
@@ -8302,7 +8302,7 @@
             <a:avLst/>
           </a:prstGeom>
           <a:solidFill>
-            <a:srgbClr val="10243C"/>
+            <a:srgbClr val="FFFFFF"/>
           </a:solidFill>
           <a:ln>
             <a:solidFill>
@@ -8331,7 +8331,7 @@
             <a:pPr algn="ctr">
               <a:defRPr sz="1200" b="1">
                 <a:solidFill>
-                  <a:srgbClr val="FFBE55"/>
+                  <a:srgbClr val="D39A28"/>
                 </a:solidFill>
               </a:defRPr>
             </a:pPr>
@@ -8346,7 +8346,7 @@
               </a:spcBef>
               <a:defRPr sz="1500">
                 <a:solidFill>
-                  <a:srgbClr val="F4F8FC"/>
+                  <a:srgbClr val="151515"/>
                 </a:solidFill>
               </a:defRPr>
             </a:pPr>
@@ -8371,7 +8371,7 @@
             <a:avLst/>
           </a:prstGeom>
           <a:solidFill>
-            <a:srgbClr val="FFBE55"/>
+            <a:srgbClr val="D39A28"/>
           </a:solidFill>
           <a:ln>
             <a:noFill/>
@@ -8414,7 +8414,7 @@
             <a:avLst/>
           </a:prstGeom>
           <a:solidFill>
-            <a:srgbClr val="10243C"/>
+            <a:srgbClr val="FFFFFF"/>
           </a:solidFill>
           <a:ln>
             <a:solidFill>
@@ -8443,7 +8443,7 @@
             <a:pPr algn="ctr">
               <a:defRPr sz="1200" b="1">
                 <a:solidFill>
-                  <a:srgbClr val="46D6C8"/>
+                  <a:srgbClr val="E6462E"/>
                 </a:solidFill>
               </a:defRPr>
             </a:pPr>
@@ -8458,7 +8458,7 @@
               </a:spcBef>
               <a:defRPr sz="1500">
                 <a:solidFill>
-                  <a:srgbClr val="F4F8FC"/>
+                  <a:srgbClr val="151515"/>
                 </a:solidFill>
               </a:defRPr>
             </a:pPr>
@@ -8483,7 +8483,7 @@
             <a:avLst/>
           </a:prstGeom>
           <a:solidFill>
-            <a:srgbClr val="46D6C8"/>
+            <a:srgbClr val="E6462E"/>
           </a:solidFill>
           <a:ln>
             <a:noFill/>
@@ -8526,7 +8526,7 @@
             <a:avLst/>
           </a:prstGeom>
           <a:solidFill>
-            <a:srgbClr val="10243C"/>
+            <a:srgbClr val="FFFFFF"/>
           </a:solidFill>
           <a:ln>
             <a:solidFill>
@@ -8555,7 +8555,7 @@
             <a:pPr algn="ctr">
               <a:defRPr sz="1200" b="1">
                 <a:solidFill>
-                  <a:srgbClr val="55A7FF"/>
+                  <a:srgbClr val="176B87"/>
                 </a:solidFill>
               </a:defRPr>
             </a:pPr>
@@ -8570,7 +8570,7 @@
               </a:spcBef>
               <a:defRPr sz="1500">
                 <a:solidFill>
-                  <a:srgbClr val="F4F8FC"/>
+                  <a:srgbClr val="151515"/>
                 </a:solidFill>
               </a:defRPr>
             </a:pPr>
@@ -8595,7 +8595,7 @@
             <a:avLst/>
           </a:prstGeom>
           <a:solidFill>
-            <a:srgbClr val="55A7FF"/>
+            <a:srgbClr val="176B87"/>
           </a:solidFill>
           <a:ln>
             <a:noFill/>
@@ -8638,7 +8638,7 @@
             <a:avLst/>
           </a:prstGeom>
           <a:solidFill>
-            <a:srgbClr val="10243C"/>
+            <a:srgbClr val="FFFFFF"/>
           </a:solidFill>
           <a:ln>
             <a:solidFill>
@@ -8667,7 +8667,7 @@
             <a:pPr algn="ctr">
               <a:defRPr sz="1200" b="1">
                 <a:solidFill>
-                  <a:srgbClr val="FFBE55"/>
+                  <a:srgbClr val="D39A28"/>
                 </a:solidFill>
               </a:defRPr>
             </a:pPr>
@@ -8682,7 +8682,7 @@
               </a:spcBef>
               <a:defRPr sz="1500">
                 <a:solidFill>
-                  <a:srgbClr val="F4F8FC"/>
+                  <a:srgbClr val="151515"/>
                 </a:solidFill>
               </a:defRPr>
             </a:pPr>
@@ -8707,7 +8707,7 @@
             <a:avLst/>
           </a:prstGeom>
           <a:solidFill>
-            <a:srgbClr val="FFBE55"/>
+            <a:srgbClr val="D39A28"/>
           </a:solidFill>
           <a:ln>
             <a:noFill/>
@@ -8760,7 +8760,7 @@
             <a:pPr>
               <a:defRPr sz="900">
                 <a:solidFill>
-                  <a:srgbClr val="9AB2C8"/>
+                  <a:srgbClr val="62666A"/>
                 </a:solidFill>
               </a:defRPr>
             </a:pPr>
@@ -8784,7 +8784,7 @@
     <p:bg>
       <p:bgPr>
         <a:solidFill>
-          <a:srgbClr val="07111F"/>
+          <a:srgbClr val="F4F1E8"/>
         </a:solidFill>
         <a:effectLst/>
       </p:bgPr>
@@ -8811,7 +8811,7 @@
             <a:avLst/>
           </a:prstGeom>
           <a:solidFill>
-            <a:srgbClr val="46D6C8"/>
+            <a:srgbClr val="E6462E"/>
           </a:solidFill>
           <a:ln>
             <a:noFill/>
@@ -8864,7 +8864,7 @@
             <a:pPr>
               <a:defRPr sz="900" b="1">
                 <a:solidFill>
-                  <a:srgbClr val="46D6C8"/>
+                  <a:srgbClr val="E6462E"/>
                 </a:solidFill>
               </a:defRPr>
             </a:pPr>
@@ -8899,7 +8899,7 @@
             <a:pPr algn="l">
               <a:defRPr sz="2700" b="1">
                 <a:solidFill>
-                  <a:srgbClr val="F4F8FC"/>
+                  <a:srgbClr val="151515"/>
                 </a:solidFill>
               </a:defRPr>
             </a:pPr>
@@ -8924,7 +8924,7 @@
             <a:avLst/>
           </a:prstGeom>
           <a:solidFill>
-            <a:srgbClr val="10243C"/>
+            <a:srgbClr val="FFFFFF"/>
           </a:solidFill>
           <a:ln>
             <a:solidFill>
@@ -8953,7 +8953,7 @@
             <a:pPr algn="ctr">
               <a:defRPr sz="1200" b="1">
                 <a:solidFill>
-                  <a:srgbClr val="46D6C8"/>
+                  <a:srgbClr val="E6462E"/>
                 </a:solidFill>
               </a:defRPr>
             </a:pPr>
@@ -8968,7 +8968,7 @@
               </a:spcBef>
               <a:defRPr sz="1500">
                 <a:solidFill>
-                  <a:srgbClr val="F4F8FC"/>
+                  <a:srgbClr val="151515"/>
                 </a:solidFill>
               </a:defRPr>
             </a:pPr>
@@ -8993,7 +8993,7 @@
             <a:avLst/>
           </a:prstGeom>
           <a:solidFill>
-            <a:srgbClr val="46D6C8"/>
+            <a:srgbClr val="E6462E"/>
           </a:solidFill>
           <a:ln>
             <a:noFill/>
@@ -9036,7 +9036,7 @@
             <a:avLst/>
           </a:prstGeom>
           <a:solidFill>
-            <a:srgbClr val="10243C"/>
+            <a:srgbClr val="FFFFFF"/>
           </a:solidFill>
           <a:ln>
             <a:solidFill>
@@ -9065,7 +9065,7 @@
             <a:pPr algn="ctr">
               <a:defRPr sz="1200" b="1">
                 <a:solidFill>
-                  <a:srgbClr val="55A7FF"/>
+                  <a:srgbClr val="176B87"/>
                 </a:solidFill>
               </a:defRPr>
             </a:pPr>
@@ -9080,7 +9080,7 @@
               </a:spcBef>
               <a:defRPr sz="1500">
                 <a:solidFill>
-                  <a:srgbClr val="F4F8FC"/>
+                  <a:srgbClr val="151515"/>
                 </a:solidFill>
               </a:defRPr>
             </a:pPr>
@@ -9105,7 +9105,7 @@
             <a:avLst/>
           </a:prstGeom>
           <a:solidFill>
-            <a:srgbClr val="55A7FF"/>
+            <a:srgbClr val="176B87"/>
           </a:solidFill>
           <a:ln>
             <a:noFill/>
@@ -9148,7 +9148,7 @@
             <a:avLst/>
           </a:prstGeom>
           <a:solidFill>
-            <a:srgbClr val="10243C"/>
+            <a:srgbClr val="FFFFFF"/>
           </a:solidFill>
           <a:ln>
             <a:solidFill>
@@ -9177,7 +9177,7 @@
             <a:pPr algn="ctr">
               <a:defRPr sz="1200" b="1">
                 <a:solidFill>
-                  <a:srgbClr val="FFBE55"/>
+                  <a:srgbClr val="D39A28"/>
                 </a:solidFill>
               </a:defRPr>
             </a:pPr>
@@ -9192,7 +9192,7 @@
               </a:spcBef>
               <a:defRPr sz="1100">
                 <a:solidFill>
-                  <a:srgbClr val="F4F8FC"/>
+                  <a:srgbClr val="151515"/>
                 </a:solidFill>
               </a:defRPr>
             </a:pPr>
@@ -9217,7 +9217,7 @@
             <a:avLst/>
           </a:prstGeom>
           <a:solidFill>
-            <a:srgbClr val="FFBE55"/>
+            <a:srgbClr val="D39A28"/>
           </a:solidFill>
           <a:ln>
             <a:noFill/>
@@ -9260,7 +9260,7 @@
             <a:avLst/>
           </a:prstGeom>
           <a:solidFill>
-            <a:srgbClr val="10243C"/>
+            <a:srgbClr val="FFFFFF"/>
           </a:solidFill>
           <a:ln>
             <a:solidFill>
@@ -9289,7 +9289,7 @@
             <a:pPr algn="ctr">
               <a:defRPr sz="1200" b="1">
                 <a:solidFill>
-                  <a:srgbClr val="46D6C8"/>
+                  <a:srgbClr val="E6462E"/>
                 </a:solidFill>
               </a:defRPr>
             </a:pPr>
@@ -9304,7 +9304,7 @@
               </a:spcBef>
               <a:defRPr sz="1100">
                 <a:solidFill>
-                  <a:srgbClr val="F4F8FC"/>
+                  <a:srgbClr val="151515"/>
                 </a:solidFill>
               </a:defRPr>
             </a:pPr>
@@ -9329,7 +9329,7 @@
             <a:avLst/>
           </a:prstGeom>
           <a:solidFill>
-            <a:srgbClr val="46D6C8"/>
+            <a:srgbClr val="E6462E"/>
           </a:solidFill>
           <a:ln>
             <a:noFill/>
@@ -9372,7 +9372,7 @@
             <a:avLst/>
           </a:prstGeom>
           <a:solidFill>
-            <a:srgbClr val="10243C"/>
+            <a:srgbClr val="FFFFFF"/>
           </a:solidFill>
           <a:ln>
             <a:solidFill>
@@ -9401,7 +9401,7 @@
             <a:pPr algn="ctr">
               <a:defRPr sz="1200" b="1">
                 <a:solidFill>
-                  <a:srgbClr val="55A7FF"/>
+                  <a:srgbClr val="176B87"/>
                 </a:solidFill>
               </a:defRPr>
             </a:pPr>
@@ -9416,7 +9416,7 @@
               </a:spcBef>
               <a:defRPr sz="1100">
                 <a:solidFill>
-                  <a:srgbClr val="F4F8FC"/>
+                  <a:srgbClr val="151515"/>
                 </a:solidFill>
               </a:defRPr>
             </a:pPr>
@@ -9441,7 +9441,7 @@
             <a:avLst/>
           </a:prstGeom>
           <a:solidFill>
-            <a:srgbClr val="55A7FF"/>
+            <a:srgbClr val="176B87"/>
           </a:solidFill>
           <a:ln>
             <a:noFill/>
@@ -9484,7 +9484,7 @@
             <a:avLst/>
           </a:prstGeom>
           <a:solidFill>
-            <a:srgbClr val="10243C"/>
+            <a:srgbClr val="FFFFFF"/>
           </a:solidFill>
           <a:ln>
             <a:solidFill>
@@ -9513,7 +9513,7 @@
             <a:pPr algn="ctr">
               <a:defRPr sz="1200" b="1">
                 <a:solidFill>
-                  <a:srgbClr val="FFBE55"/>
+                  <a:srgbClr val="D39A28"/>
                 </a:solidFill>
               </a:defRPr>
             </a:pPr>
@@ -9528,7 +9528,7 @@
               </a:spcBef>
               <a:defRPr sz="1500">
                 <a:solidFill>
-                  <a:srgbClr val="F4F8FC"/>
+                  <a:srgbClr val="151515"/>
                 </a:solidFill>
               </a:defRPr>
             </a:pPr>
@@ -9553,7 +9553,7 @@
             <a:avLst/>
           </a:prstGeom>
           <a:solidFill>
-            <a:srgbClr val="FFBE55"/>
+            <a:srgbClr val="D39A28"/>
           </a:solidFill>
           <a:ln>
             <a:noFill/>
@@ -9606,7 +9606,7 @@
             <a:pPr>
               <a:defRPr sz="900">
                 <a:solidFill>
-                  <a:srgbClr val="9AB2C8"/>
+                  <a:srgbClr val="62666A"/>
                 </a:solidFill>
               </a:defRPr>
             </a:pPr>
@@ -9630,7 +9630,7 @@
     <p:bg>
       <p:bgPr>
         <a:solidFill>
-          <a:srgbClr val="07111F"/>
+          <a:srgbClr val="F4F1E8"/>
         </a:solidFill>
         <a:effectLst/>
       </p:bgPr>
@@ -9657,7 +9657,7 @@
             <a:avLst/>
           </a:prstGeom>
           <a:solidFill>
-            <a:srgbClr val="46D6C8"/>
+            <a:srgbClr val="E6462E"/>
           </a:solidFill>
           <a:ln>
             <a:noFill/>
@@ -9710,7 +9710,7 @@
             <a:pPr>
               <a:defRPr sz="900" b="1">
                 <a:solidFill>
-                  <a:srgbClr val="46D6C8"/>
+                  <a:srgbClr val="E6462E"/>
                 </a:solidFill>
               </a:defRPr>
             </a:pPr>
@@ -9745,7 +9745,7 @@
             <a:pPr algn="l">
               <a:defRPr sz="2700" b="1">
                 <a:solidFill>
-                  <a:srgbClr val="F4F8FC"/>
+                  <a:srgbClr val="151515"/>
                 </a:solidFill>
               </a:defRPr>
             </a:pPr>
@@ -9770,7 +9770,7 @@
             <a:avLst/>
           </a:prstGeom>
           <a:solidFill>
-            <a:srgbClr val="10243C"/>
+            <a:srgbClr val="FFFFFF"/>
           </a:solidFill>
           <a:ln>
             <a:solidFill>
@@ -9799,7 +9799,7 @@
             <a:pPr algn="ctr">
               <a:defRPr sz="1200" b="1">
                 <a:solidFill>
-                  <a:srgbClr val="46D6C8"/>
+                  <a:srgbClr val="E6462E"/>
                 </a:solidFill>
               </a:defRPr>
             </a:pPr>
@@ -9814,7 +9814,7 @@
               </a:spcBef>
               <a:defRPr sz="1500">
                 <a:solidFill>
-                  <a:srgbClr val="F4F8FC"/>
+                  <a:srgbClr val="151515"/>
                 </a:solidFill>
               </a:defRPr>
             </a:pPr>
@@ -9839,7 +9839,7 @@
             <a:avLst/>
           </a:prstGeom>
           <a:solidFill>
-            <a:srgbClr val="46D6C8"/>
+            <a:srgbClr val="E6462E"/>
           </a:solidFill>
           <a:ln>
             <a:noFill/>
@@ -9882,7 +9882,7 @@
             <a:avLst/>
           </a:prstGeom>
           <a:solidFill>
-            <a:srgbClr val="10243C"/>
+            <a:srgbClr val="FFFFFF"/>
           </a:solidFill>
           <a:ln>
             <a:solidFill>
@@ -9911,7 +9911,7 @@
             <a:pPr algn="ctr">
               <a:defRPr sz="1200" b="1">
                 <a:solidFill>
-                  <a:srgbClr val="55A7FF"/>
+                  <a:srgbClr val="176B87"/>
                 </a:solidFill>
               </a:defRPr>
             </a:pPr>
@@ -9926,7 +9926,7 @@
               </a:spcBef>
               <a:defRPr sz="1100">
                 <a:solidFill>
-                  <a:srgbClr val="F4F8FC"/>
+                  <a:srgbClr val="151515"/>
                 </a:solidFill>
               </a:defRPr>
             </a:pPr>
@@ -9951,7 +9951,7 @@
             <a:avLst/>
           </a:prstGeom>
           <a:solidFill>
-            <a:srgbClr val="55A7FF"/>
+            <a:srgbClr val="176B87"/>
           </a:solidFill>
           <a:ln>
             <a:noFill/>
@@ -9994,7 +9994,7 @@
             <a:avLst/>
           </a:prstGeom>
           <a:solidFill>
-            <a:srgbClr val="10243C"/>
+            <a:srgbClr val="FFFFFF"/>
           </a:solidFill>
           <a:ln>
             <a:solidFill>
@@ -10023,7 +10023,7 @@
             <a:pPr algn="ctr">
               <a:defRPr sz="1200" b="1">
                 <a:solidFill>
-                  <a:srgbClr val="FFBE55"/>
+                  <a:srgbClr val="D39A28"/>
                 </a:solidFill>
               </a:defRPr>
             </a:pPr>
@@ -10038,7 +10038,7 @@
               </a:spcBef>
               <a:defRPr sz="1500">
                 <a:solidFill>
-                  <a:srgbClr val="F4F8FC"/>
+                  <a:srgbClr val="151515"/>
                 </a:solidFill>
               </a:defRPr>
             </a:pPr>
@@ -10063,7 +10063,7 @@
             <a:avLst/>
           </a:prstGeom>
           <a:solidFill>
-            <a:srgbClr val="FFBE55"/>
+            <a:srgbClr val="D39A28"/>
           </a:solidFill>
           <a:ln>
             <a:noFill/>
@@ -10106,7 +10106,7 @@
             <a:avLst/>
           </a:prstGeom>
           <a:solidFill>
-            <a:srgbClr val="10243C"/>
+            <a:srgbClr val="FFFFFF"/>
           </a:solidFill>
           <a:ln>
             <a:solidFill>
@@ -10135,7 +10135,7 @@
             <a:pPr algn="ctr">
               <a:defRPr sz="1200" b="1">
                 <a:solidFill>
-                  <a:srgbClr val="46D6C8"/>
+                  <a:srgbClr val="E6462E"/>
                 </a:solidFill>
               </a:defRPr>
             </a:pPr>
@@ -10150,7 +10150,7 @@
               </a:spcBef>
               <a:defRPr sz="1500">
                 <a:solidFill>
-                  <a:srgbClr val="F4F8FC"/>
+                  <a:srgbClr val="151515"/>
                 </a:solidFill>
               </a:defRPr>
             </a:pPr>
@@ -10175,7 +10175,7 @@
             <a:avLst/>
           </a:prstGeom>
           <a:solidFill>
-            <a:srgbClr val="46D6C8"/>
+            <a:srgbClr val="E6462E"/>
           </a:solidFill>
           <a:ln>
             <a:noFill/>
@@ -10218,7 +10218,7 @@
             <a:avLst/>
           </a:prstGeom>
           <a:solidFill>
-            <a:srgbClr val="10243C"/>
+            <a:srgbClr val="FFFFFF"/>
           </a:solidFill>
           <a:ln>
             <a:solidFill>
@@ -10247,7 +10247,7 @@
             <a:pPr algn="ctr">
               <a:defRPr sz="1200" b="1">
                 <a:solidFill>
-                  <a:srgbClr val="55A7FF"/>
+                  <a:srgbClr val="176B87"/>
                 </a:solidFill>
               </a:defRPr>
             </a:pPr>
@@ -10262,7 +10262,7 @@
               </a:spcBef>
               <a:defRPr sz="1500">
                 <a:solidFill>
-                  <a:srgbClr val="F4F8FC"/>
+                  <a:srgbClr val="151515"/>
                 </a:solidFill>
               </a:defRPr>
             </a:pPr>
@@ -10287,7 +10287,7 @@
             <a:avLst/>
           </a:prstGeom>
           <a:solidFill>
-            <a:srgbClr val="55A7FF"/>
+            <a:srgbClr val="176B87"/>
           </a:solidFill>
           <a:ln>
             <a:noFill/>
@@ -10330,7 +10330,7 @@
             <a:avLst/>
           </a:prstGeom>
           <a:solidFill>
-            <a:srgbClr val="10243C"/>
+            <a:srgbClr val="FFFFFF"/>
           </a:solidFill>
           <a:ln>
             <a:solidFill>
@@ -10359,7 +10359,7 @@
             <a:pPr algn="ctr">
               <a:defRPr sz="1200" b="1">
                 <a:solidFill>
-                  <a:srgbClr val="FFBE55"/>
+                  <a:srgbClr val="D39A28"/>
                 </a:solidFill>
               </a:defRPr>
             </a:pPr>
@@ -10374,7 +10374,7 @@
               </a:spcBef>
               <a:defRPr sz="1100">
                 <a:solidFill>
-                  <a:srgbClr val="F4F8FC"/>
+                  <a:srgbClr val="151515"/>
                 </a:solidFill>
               </a:defRPr>
             </a:pPr>
@@ -10399,7 +10399,7 @@
             <a:avLst/>
           </a:prstGeom>
           <a:solidFill>
-            <a:srgbClr val="FFBE55"/>
+            <a:srgbClr val="D39A28"/>
           </a:solidFill>
           <a:ln>
             <a:noFill/>
@@ -10452,7 +10452,7 @@
             <a:pPr>
               <a:defRPr sz="900">
                 <a:solidFill>
-                  <a:srgbClr val="9AB2C8"/>
+                  <a:srgbClr val="62666A"/>
                 </a:solidFill>
               </a:defRPr>
             </a:pPr>
@@ -10476,7 +10476,7 @@
     <p:bg>
       <p:bgPr>
         <a:solidFill>
-          <a:srgbClr val="07111F"/>
+          <a:srgbClr val="F4F1E8"/>
         </a:solidFill>
         <a:effectLst/>
       </p:bgPr>
@@ -10503,7 +10503,7 @@
             <a:avLst/>
           </a:prstGeom>
           <a:solidFill>
-            <a:srgbClr val="46D6C8"/>
+            <a:srgbClr val="E6462E"/>
           </a:solidFill>
           <a:ln>
             <a:noFill/>
@@ -10556,7 +10556,7 @@
             <a:pPr>
               <a:defRPr sz="900" b="1">
                 <a:solidFill>
-                  <a:srgbClr val="46D6C8"/>
+                  <a:srgbClr val="E6462E"/>
                 </a:solidFill>
               </a:defRPr>
             </a:pPr>
@@ -10591,7 +10591,7 @@
             <a:pPr algn="l">
               <a:defRPr sz="2700" b="1">
                 <a:solidFill>
-                  <a:srgbClr val="F4F8FC"/>
+                  <a:srgbClr val="151515"/>
                 </a:solidFill>
               </a:defRPr>
             </a:pPr>
@@ -10616,7 +10616,7 @@
             <a:avLst/>
           </a:prstGeom>
           <a:solidFill>
-            <a:srgbClr val="10243C"/>
+            <a:srgbClr val="FFFFFF"/>
           </a:solidFill>
           <a:ln>
             <a:solidFill>
@@ -10645,7 +10645,7 @@
             <a:pPr algn="ctr">
               <a:defRPr sz="1200" b="1">
                 <a:solidFill>
-                  <a:srgbClr val="46D6C8"/>
+                  <a:srgbClr val="E6462E"/>
                 </a:solidFill>
               </a:defRPr>
             </a:pPr>
@@ -10660,7 +10660,7 @@
               </a:spcBef>
               <a:defRPr sz="1100">
                 <a:solidFill>
-                  <a:srgbClr val="F4F8FC"/>
+                  <a:srgbClr val="151515"/>
                 </a:solidFill>
               </a:defRPr>
             </a:pPr>
@@ -10685,7 +10685,7 @@
             <a:avLst/>
           </a:prstGeom>
           <a:solidFill>
-            <a:srgbClr val="46D6C8"/>
+            <a:srgbClr val="E6462E"/>
           </a:solidFill>
           <a:ln>
             <a:noFill/>
@@ -10728,7 +10728,7 @@
             <a:avLst/>
           </a:prstGeom>
           <a:solidFill>
-            <a:srgbClr val="10243C"/>
+            <a:srgbClr val="FFFFFF"/>
           </a:solidFill>
           <a:ln>
             <a:solidFill>
@@ -10757,7 +10757,7 @@
             <a:pPr algn="ctr">
               <a:defRPr sz="1200" b="1">
                 <a:solidFill>
-                  <a:srgbClr val="55A7FF"/>
+                  <a:srgbClr val="176B87"/>
                 </a:solidFill>
               </a:defRPr>
             </a:pPr>
@@ -10772,7 +10772,7 @@
               </a:spcBef>
               <a:defRPr sz="1100">
                 <a:solidFill>
-                  <a:srgbClr val="F4F8FC"/>
+                  <a:srgbClr val="151515"/>
                 </a:solidFill>
               </a:defRPr>
             </a:pPr>
@@ -10797,7 +10797,7 @@
             <a:avLst/>
           </a:prstGeom>
           <a:solidFill>
-            <a:srgbClr val="55A7FF"/>
+            <a:srgbClr val="176B87"/>
           </a:solidFill>
           <a:ln>
             <a:noFill/>
@@ -10840,7 +10840,7 @@
             <a:avLst/>
           </a:prstGeom>
           <a:solidFill>
-            <a:srgbClr val="10243C"/>
+            <a:srgbClr val="FFFFFF"/>
           </a:solidFill>
           <a:ln>
             <a:solidFill>
@@ -10869,7 +10869,7 @@
             <a:pPr algn="ctr">
               <a:defRPr sz="1200" b="1">
                 <a:solidFill>
-                  <a:srgbClr val="FFBE55"/>
+                  <a:srgbClr val="D39A28"/>
                 </a:solidFill>
               </a:defRPr>
             </a:pPr>
@@ -10884,7 +10884,7 @@
               </a:spcBef>
               <a:defRPr sz="1100">
                 <a:solidFill>
-                  <a:srgbClr val="F4F8FC"/>
+                  <a:srgbClr val="151515"/>
                 </a:solidFill>
               </a:defRPr>
             </a:pPr>
@@ -10909,7 +10909,7 @@
             <a:avLst/>
           </a:prstGeom>
           <a:solidFill>
-            <a:srgbClr val="FFBE55"/>
+            <a:srgbClr val="D39A28"/>
           </a:solidFill>
           <a:ln>
             <a:noFill/>
@@ -10952,7 +10952,7 @@
             <a:avLst/>
           </a:prstGeom>
           <a:solidFill>
-            <a:srgbClr val="10243C"/>
+            <a:srgbClr val="FFFFFF"/>
           </a:solidFill>
           <a:ln>
             <a:solidFill>
@@ -10981,7 +10981,7 @@
             <a:pPr algn="ctr">
               <a:defRPr sz="1200" b="1">
                 <a:solidFill>
-                  <a:srgbClr val="46D6C8"/>
+                  <a:srgbClr val="E6462E"/>
                 </a:solidFill>
               </a:defRPr>
             </a:pPr>
@@ -10996,7 +10996,7 @@
               </a:spcBef>
               <a:defRPr sz="1100">
                 <a:solidFill>
-                  <a:srgbClr val="F4F8FC"/>
+                  <a:srgbClr val="151515"/>
                 </a:solidFill>
               </a:defRPr>
             </a:pPr>
@@ -11021,7 +11021,7 @@
             <a:avLst/>
           </a:prstGeom>
           <a:solidFill>
-            <a:srgbClr val="46D6C8"/>
+            <a:srgbClr val="E6462E"/>
           </a:solidFill>
           <a:ln>
             <a:noFill/>
@@ -11074,7 +11074,7 @@
             <a:pPr>
               <a:defRPr sz="900">
                 <a:solidFill>
-                  <a:srgbClr val="9AB2C8"/>
+                  <a:srgbClr val="62666A"/>
                 </a:solidFill>
               </a:defRPr>
             </a:pPr>
@@ -11098,7 +11098,7 @@
     <p:bg>
       <p:bgPr>
         <a:solidFill>
-          <a:srgbClr val="07111F"/>
+          <a:srgbClr val="F4F1E8"/>
         </a:solidFill>
         <a:effectLst/>
       </p:bgPr>
@@ -11125,7 +11125,7 @@
             <a:avLst/>
           </a:prstGeom>
           <a:solidFill>
-            <a:srgbClr val="46D6C8"/>
+            <a:srgbClr val="E6462E"/>
           </a:solidFill>
           <a:ln>
             <a:noFill/>
@@ -11178,7 +11178,7 @@
             <a:pPr>
               <a:defRPr sz="900" b="1">
                 <a:solidFill>
-                  <a:srgbClr val="46D6C8"/>
+                  <a:srgbClr val="E6462E"/>
                 </a:solidFill>
               </a:defRPr>
             </a:pPr>
@@ -11213,7 +11213,7 @@
             <a:pPr algn="l">
               <a:defRPr sz="2700" b="1">
                 <a:solidFill>
-                  <a:srgbClr val="F4F8FC"/>
+                  <a:srgbClr val="151515"/>
                 </a:solidFill>
               </a:defRPr>
             </a:pPr>
@@ -11238,7 +11238,7 @@
             <a:avLst/>
           </a:prstGeom>
           <a:solidFill>
-            <a:srgbClr val="10243C"/>
+            <a:srgbClr val="FFFFFF"/>
           </a:solidFill>
           <a:ln>
             <a:solidFill>
@@ -11267,7 +11267,7 @@
             <a:pPr algn="ctr">
               <a:defRPr sz="1200" b="1">
                 <a:solidFill>
-                  <a:srgbClr val="46D6C8"/>
+                  <a:srgbClr val="E6462E"/>
                 </a:solidFill>
               </a:defRPr>
             </a:pPr>
@@ -11282,7 +11282,7 @@
               </a:spcBef>
               <a:defRPr sz="1100">
                 <a:solidFill>
-                  <a:srgbClr val="F4F8FC"/>
+                  <a:srgbClr val="151515"/>
                 </a:solidFill>
               </a:defRPr>
             </a:pPr>
@@ -11307,7 +11307,7 @@
             <a:avLst/>
           </a:prstGeom>
           <a:solidFill>
-            <a:srgbClr val="46D6C8"/>
+            <a:srgbClr val="E6462E"/>
           </a:solidFill>
           <a:ln>
             <a:noFill/>
@@ -11350,7 +11350,7 @@
             <a:avLst/>
           </a:prstGeom>
           <a:solidFill>
-            <a:srgbClr val="10243C"/>
+            <a:srgbClr val="FFFFFF"/>
           </a:solidFill>
           <a:ln>
             <a:solidFill>
@@ -11379,7 +11379,7 @@
             <a:pPr algn="ctr">
               <a:defRPr sz="1200" b="1">
                 <a:solidFill>
-                  <a:srgbClr val="55A7FF"/>
+                  <a:srgbClr val="176B87"/>
                 </a:solidFill>
               </a:defRPr>
             </a:pPr>
@@ -11394,7 +11394,7 @@
               </a:spcBef>
               <a:defRPr sz="1500">
                 <a:solidFill>
-                  <a:srgbClr val="F4F8FC"/>
+                  <a:srgbClr val="151515"/>
                 </a:solidFill>
               </a:defRPr>
             </a:pPr>
@@ -11419,7 +11419,7 @@
             <a:avLst/>
           </a:prstGeom>
           <a:solidFill>
-            <a:srgbClr val="55A7FF"/>
+            <a:srgbClr val="176B87"/>
           </a:solidFill>
           <a:ln>
             <a:noFill/>
@@ -11462,7 +11462,7 @@
             <a:avLst/>
           </a:prstGeom>
           <a:solidFill>
-            <a:srgbClr val="10243C"/>
+            <a:srgbClr val="FFFFFF"/>
           </a:solidFill>
           <a:ln>
             <a:solidFill>
@@ -11491,7 +11491,7 @@
             <a:pPr algn="ctr">
               <a:defRPr sz="1200" b="1">
                 <a:solidFill>
-                  <a:srgbClr val="FFBE55"/>
+                  <a:srgbClr val="D39A28"/>
                 </a:solidFill>
               </a:defRPr>
             </a:pPr>
@@ -11506,7 +11506,7 @@
               </a:spcBef>
               <a:defRPr sz="1100">
                 <a:solidFill>
-                  <a:srgbClr val="F4F8FC"/>
+                  <a:srgbClr val="151515"/>
                 </a:solidFill>
               </a:defRPr>
             </a:pPr>
@@ -11531,7 +11531,7 @@
             <a:avLst/>
           </a:prstGeom>
           <a:solidFill>
-            <a:srgbClr val="FFBE55"/>
+            <a:srgbClr val="D39A28"/>
           </a:solidFill>
           <a:ln>
             <a:noFill/>
@@ -11584,7 +11584,7 @@
             <a:pPr>
               <a:defRPr sz="900">
                 <a:solidFill>
-                  <a:srgbClr val="9AB2C8"/>
+                  <a:srgbClr val="62666A"/>
                 </a:solidFill>
               </a:defRPr>
             </a:pPr>
@@ -11608,7 +11608,7 @@
     <p:bg>
       <p:bgPr>
         <a:solidFill>
-          <a:srgbClr val="07111F"/>
+          <a:srgbClr val="F4F1E8"/>
         </a:solidFill>
         <a:effectLst/>
       </p:bgPr>
@@ -11635,7 +11635,7 @@
             <a:avLst/>
           </a:prstGeom>
           <a:solidFill>
-            <a:srgbClr val="46D6C8"/>
+            <a:srgbClr val="E6462E"/>
           </a:solidFill>
           <a:ln>
             <a:noFill/>
@@ -11688,7 +11688,7 @@
             <a:pPr>
               <a:defRPr sz="900" b="1">
                 <a:solidFill>
-                  <a:srgbClr val="46D6C8"/>
+                  <a:srgbClr val="E6462E"/>
                 </a:solidFill>
               </a:defRPr>
             </a:pPr>
@@ -11723,7 +11723,7 @@
             <a:pPr algn="l">
               <a:defRPr sz="2700" b="1">
                 <a:solidFill>
-                  <a:srgbClr val="F4F8FC"/>
+                  <a:srgbClr val="151515"/>
                 </a:solidFill>
               </a:defRPr>
             </a:pPr>
@@ -11748,11 +11748,11 @@
             <a:avLst/>
           </a:prstGeom>
           <a:solidFill>
-            <a:srgbClr val="163451"/>
+            <a:srgbClr val="E8E3D8"/>
           </a:solidFill>
           <a:ln>
             <a:solidFill>
-              <a:srgbClr val="55A7FF"/>
+              <a:srgbClr val="176B87"/>
             </a:solidFill>
           </a:ln>
         </p:spPr>
@@ -11777,7 +11777,7 @@
             <a:pPr algn="ctr">
               <a:defRPr sz="1100" b="1">
                 <a:solidFill>
-                  <a:srgbClr val="F4F8FC"/>
+                  <a:srgbClr val="151515"/>
                 </a:solidFill>
               </a:defRPr>
             </a:pPr>
@@ -11802,11 +11802,11 @@
             <a:avLst/>
           </a:prstGeom>
           <a:solidFill>
-            <a:srgbClr val="163451"/>
+            <a:srgbClr val="E8E3D8"/>
           </a:solidFill>
           <a:ln>
             <a:solidFill>
-              <a:srgbClr val="55A7FF"/>
+              <a:srgbClr val="176B87"/>
             </a:solidFill>
           </a:ln>
         </p:spPr>
@@ -11831,7 +11831,7 @@
             <a:pPr algn="ctr">
               <a:defRPr sz="1100" b="1">
                 <a:solidFill>
-                  <a:srgbClr val="F4F8FC"/>
+                  <a:srgbClr val="151515"/>
                 </a:solidFill>
               </a:defRPr>
             </a:pPr>
@@ -11866,7 +11866,7 @@
             <a:pPr algn="ctr">
               <a:defRPr sz="1100">
                 <a:solidFill>
-                  <a:srgbClr val="46D6C8"/>
+                  <a:srgbClr val="E6462E"/>
                 </a:solidFill>
               </a:defRPr>
             </a:pPr>
@@ -11891,11 +11891,11 @@
             <a:avLst/>
           </a:prstGeom>
           <a:solidFill>
-            <a:srgbClr val="163451"/>
+            <a:srgbClr val="E8E3D8"/>
           </a:solidFill>
           <a:ln>
             <a:solidFill>
-              <a:srgbClr val="55A7FF"/>
+              <a:srgbClr val="176B87"/>
             </a:solidFill>
           </a:ln>
         </p:spPr>
@@ -11920,7 +11920,7 @@
             <a:pPr algn="ctr">
               <a:defRPr sz="1100" b="1">
                 <a:solidFill>
-                  <a:srgbClr val="F4F8FC"/>
+                  <a:srgbClr val="151515"/>
                 </a:solidFill>
               </a:defRPr>
             </a:pPr>
@@ -11945,11 +11945,11 @@
             <a:avLst/>
           </a:prstGeom>
           <a:solidFill>
-            <a:srgbClr val="163451"/>
+            <a:srgbClr val="E8E3D8"/>
           </a:solidFill>
           <a:ln>
             <a:solidFill>
-              <a:srgbClr val="55A7FF"/>
+              <a:srgbClr val="176B87"/>
             </a:solidFill>
           </a:ln>
         </p:spPr>
@@ -11974,7 +11974,7 @@
             <a:pPr algn="ctr">
               <a:defRPr sz="1100" b="1">
                 <a:solidFill>
-                  <a:srgbClr val="F4F8FC"/>
+                  <a:srgbClr val="151515"/>
                 </a:solidFill>
               </a:defRPr>
             </a:pPr>
@@ -12009,7 +12009,7 @@
             <a:pPr algn="ctr">
               <a:defRPr sz="1100">
                 <a:solidFill>
-                  <a:srgbClr val="46D6C8"/>
+                  <a:srgbClr val="E6462E"/>
                 </a:solidFill>
               </a:defRPr>
             </a:pPr>
@@ -12034,11 +12034,11 @@
             <a:avLst/>
           </a:prstGeom>
           <a:solidFill>
-            <a:srgbClr val="163451"/>
+            <a:srgbClr val="E8E3D8"/>
           </a:solidFill>
           <a:ln>
             <a:solidFill>
-              <a:srgbClr val="55A7FF"/>
+              <a:srgbClr val="176B87"/>
             </a:solidFill>
           </a:ln>
         </p:spPr>
@@ -12063,7 +12063,7 @@
             <a:pPr algn="ctr">
               <a:defRPr sz="1100" b="1">
                 <a:solidFill>
-                  <a:srgbClr val="F4F8FC"/>
+                  <a:srgbClr val="151515"/>
                 </a:solidFill>
               </a:defRPr>
             </a:pPr>
@@ -12088,11 +12088,11 @@
             <a:avLst/>
           </a:prstGeom>
           <a:solidFill>
-            <a:srgbClr val="163451"/>
+            <a:srgbClr val="E8E3D8"/>
           </a:solidFill>
           <a:ln>
             <a:solidFill>
-              <a:srgbClr val="55A7FF"/>
+              <a:srgbClr val="176B87"/>
             </a:solidFill>
           </a:ln>
         </p:spPr>
@@ -12117,7 +12117,7 @@
             <a:pPr algn="ctr">
               <a:defRPr sz="1100" b="1">
                 <a:solidFill>
-                  <a:srgbClr val="F4F8FC"/>
+                  <a:srgbClr val="151515"/>
                 </a:solidFill>
               </a:defRPr>
             </a:pPr>
@@ -12152,7 +12152,7 @@
             <a:pPr algn="ctr">
               <a:defRPr sz="1100">
                 <a:solidFill>
-                  <a:srgbClr val="46D6C8"/>
+                  <a:srgbClr val="E6462E"/>
                 </a:solidFill>
               </a:defRPr>
             </a:pPr>
@@ -12177,11 +12177,11 @@
             <a:avLst/>
           </a:prstGeom>
           <a:solidFill>
-            <a:srgbClr val="163451"/>
+            <a:srgbClr val="E8E3D8"/>
           </a:solidFill>
           <a:ln>
             <a:solidFill>
-              <a:srgbClr val="55A7FF"/>
+              <a:srgbClr val="176B87"/>
             </a:solidFill>
           </a:ln>
         </p:spPr>
@@ -12206,7 +12206,7 @@
             <a:pPr algn="ctr">
               <a:defRPr sz="1100" b="1">
                 <a:solidFill>
-                  <a:srgbClr val="F4F8FC"/>
+                  <a:srgbClr val="151515"/>
                 </a:solidFill>
               </a:defRPr>
             </a:pPr>
@@ -12231,11 +12231,11 @@
             <a:avLst/>
           </a:prstGeom>
           <a:solidFill>
-            <a:srgbClr val="163451"/>
+            <a:srgbClr val="E8E3D8"/>
           </a:solidFill>
           <a:ln>
             <a:solidFill>
-              <a:srgbClr val="55A7FF"/>
+              <a:srgbClr val="176B87"/>
             </a:solidFill>
           </a:ln>
         </p:spPr>
@@ -12260,7 +12260,7 @@
             <a:pPr algn="ctr">
               <a:defRPr sz="1100" b="1">
                 <a:solidFill>
-                  <a:srgbClr val="F4F8FC"/>
+                  <a:srgbClr val="151515"/>
                 </a:solidFill>
               </a:defRPr>
             </a:pPr>
@@ -12295,7 +12295,7 @@
             <a:pPr algn="ctr">
               <a:defRPr sz="1100">
                 <a:solidFill>
-                  <a:srgbClr val="46D6C8"/>
+                  <a:srgbClr val="E6462E"/>
                 </a:solidFill>
               </a:defRPr>
             </a:pPr>
@@ -12320,11 +12320,11 @@
             <a:avLst/>
           </a:prstGeom>
           <a:solidFill>
-            <a:srgbClr val="163451"/>
+            <a:srgbClr val="E8E3D8"/>
           </a:solidFill>
           <a:ln>
             <a:solidFill>
-              <a:srgbClr val="55A7FF"/>
+              <a:srgbClr val="176B87"/>
             </a:solidFill>
           </a:ln>
         </p:spPr>
@@ -12349,7 +12349,7 @@
             <a:pPr algn="ctr">
               <a:defRPr sz="1100" b="1">
                 <a:solidFill>
-                  <a:srgbClr val="F4F8FC"/>
+                  <a:srgbClr val="151515"/>
                 </a:solidFill>
               </a:defRPr>
             </a:pPr>
@@ -12374,11 +12374,11 @@
             <a:avLst/>
           </a:prstGeom>
           <a:solidFill>
-            <a:srgbClr val="163451"/>
+            <a:srgbClr val="E8E3D8"/>
           </a:solidFill>
           <a:ln>
             <a:solidFill>
-              <a:srgbClr val="55A7FF"/>
+              <a:srgbClr val="176B87"/>
             </a:solidFill>
           </a:ln>
         </p:spPr>
@@ -12403,7 +12403,7 @@
             <a:pPr algn="ctr">
               <a:defRPr sz="1100" b="1">
                 <a:solidFill>
-                  <a:srgbClr val="F4F8FC"/>
+                  <a:srgbClr val="151515"/>
                 </a:solidFill>
               </a:defRPr>
             </a:pPr>
@@ -12438,7 +12438,7 @@
             <a:pPr algn="ctr">
               <a:defRPr sz="1100">
                 <a:solidFill>
-                  <a:srgbClr val="46D6C8"/>
+                  <a:srgbClr val="E6462E"/>
                 </a:solidFill>
               </a:defRPr>
             </a:pPr>
@@ -12463,11 +12463,11 @@
             <a:avLst/>
           </a:prstGeom>
           <a:solidFill>
-            <a:srgbClr val="163451"/>
+            <a:srgbClr val="E8E3D8"/>
           </a:solidFill>
           <a:ln>
             <a:solidFill>
-              <a:srgbClr val="55A7FF"/>
+              <a:srgbClr val="176B87"/>
             </a:solidFill>
           </a:ln>
         </p:spPr>
@@ -12492,7 +12492,7 @@
             <a:pPr algn="ctr">
               <a:defRPr sz="1100" b="1">
                 <a:solidFill>
-                  <a:srgbClr val="F4F8FC"/>
+                  <a:srgbClr val="151515"/>
                 </a:solidFill>
               </a:defRPr>
             </a:pPr>
@@ -12517,11 +12517,11 @@
             <a:avLst/>
           </a:prstGeom>
           <a:solidFill>
-            <a:srgbClr val="163451"/>
+            <a:srgbClr val="E8E3D8"/>
           </a:solidFill>
           <a:ln>
             <a:solidFill>
-              <a:srgbClr val="55A7FF"/>
+              <a:srgbClr val="176B87"/>
             </a:solidFill>
           </a:ln>
         </p:spPr>
@@ -12546,7 +12546,7 @@
             <a:pPr algn="ctr">
               <a:defRPr sz="1100" b="1">
                 <a:solidFill>
-                  <a:srgbClr val="F4F8FC"/>
+                  <a:srgbClr val="151515"/>
                 </a:solidFill>
               </a:defRPr>
             </a:pPr>
@@ -12581,7 +12581,7 @@
             <a:pPr algn="ctr">
               <a:defRPr sz="1100">
                 <a:solidFill>
-                  <a:srgbClr val="46D6C8"/>
+                  <a:srgbClr val="E6462E"/>
                 </a:solidFill>
               </a:defRPr>
             </a:pPr>
@@ -12606,11 +12606,11 @@
             <a:avLst/>
           </a:prstGeom>
           <a:solidFill>
-            <a:srgbClr val="163451"/>
+            <a:srgbClr val="E8E3D8"/>
           </a:solidFill>
           <a:ln>
             <a:solidFill>
-              <a:srgbClr val="55A7FF"/>
+              <a:srgbClr val="176B87"/>
             </a:solidFill>
           </a:ln>
         </p:spPr>
@@ -12635,7 +12635,7 @@
             <a:pPr algn="ctr">
               <a:defRPr sz="1100" b="1">
                 <a:solidFill>
-                  <a:srgbClr val="F4F8FC"/>
+                  <a:srgbClr val="151515"/>
                 </a:solidFill>
               </a:defRPr>
             </a:pPr>
@@ -12660,11 +12660,11 @@
             <a:avLst/>
           </a:prstGeom>
           <a:solidFill>
-            <a:srgbClr val="163451"/>
+            <a:srgbClr val="E8E3D8"/>
           </a:solidFill>
           <a:ln>
             <a:solidFill>
-              <a:srgbClr val="55A7FF"/>
+              <a:srgbClr val="176B87"/>
             </a:solidFill>
           </a:ln>
         </p:spPr>
@@ -12689,7 +12689,7 @@
             <a:pPr algn="ctr">
               <a:defRPr sz="1100" b="1">
                 <a:solidFill>
-                  <a:srgbClr val="F4F8FC"/>
+                  <a:srgbClr val="151515"/>
                 </a:solidFill>
               </a:defRPr>
             </a:pPr>
@@ -12724,7 +12724,7 @@
             <a:pPr algn="ctr">
               <a:defRPr sz="1100">
                 <a:solidFill>
-                  <a:srgbClr val="46D6C8"/>
+                  <a:srgbClr val="E6462E"/>
                 </a:solidFill>
               </a:defRPr>
             </a:pPr>
@@ -12749,11 +12749,11 @@
             <a:avLst/>
           </a:prstGeom>
           <a:solidFill>
-            <a:srgbClr val="163451"/>
+            <a:srgbClr val="E8E3D8"/>
           </a:solidFill>
           <a:ln>
             <a:solidFill>
-              <a:srgbClr val="55A7FF"/>
+              <a:srgbClr val="176B87"/>
             </a:solidFill>
           </a:ln>
         </p:spPr>
@@ -12778,7 +12778,7 @@
             <a:pPr algn="ctr">
               <a:defRPr sz="1100" b="1">
                 <a:solidFill>
-                  <a:srgbClr val="F4F8FC"/>
+                  <a:srgbClr val="151515"/>
                 </a:solidFill>
               </a:defRPr>
             </a:pPr>
@@ -12803,11 +12803,11 @@
             <a:avLst/>
           </a:prstGeom>
           <a:solidFill>
-            <a:srgbClr val="163451"/>
+            <a:srgbClr val="E8E3D8"/>
           </a:solidFill>
           <a:ln>
             <a:solidFill>
-              <a:srgbClr val="55A7FF"/>
+              <a:srgbClr val="176B87"/>
             </a:solidFill>
           </a:ln>
         </p:spPr>
@@ -12832,7 +12832,7 @@
             <a:pPr algn="ctr">
               <a:defRPr sz="1100" b="1">
                 <a:solidFill>
-                  <a:srgbClr val="F4F8FC"/>
+                  <a:srgbClr val="151515"/>
                 </a:solidFill>
               </a:defRPr>
             </a:pPr>
@@ -12867,7 +12867,7 @@
             <a:pPr algn="ctr">
               <a:defRPr sz="1100">
                 <a:solidFill>
-                  <a:srgbClr val="46D6C8"/>
+                  <a:srgbClr val="E6462E"/>
                 </a:solidFill>
               </a:defRPr>
             </a:pPr>
@@ -12892,11 +12892,11 @@
             <a:avLst/>
           </a:prstGeom>
           <a:solidFill>
-            <a:srgbClr val="163451"/>
+            <a:srgbClr val="E8E3D8"/>
           </a:solidFill>
           <a:ln>
             <a:solidFill>
-              <a:srgbClr val="55A7FF"/>
+              <a:srgbClr val="176B87"/>
             </a:solidFill>
           </a:ln>
         </p:spPr>
@@ -12921,7 +12921,7 @@
             <a:pPr algn="ctr">
               <a:defRPr sz="1100" b="1">
                 <a:solidFill>
-                  <a:srgbClr val="F4F8FC"/>
+                  <a:srgbClr val="151515"/>
                 </a:solidFill>
               </a:defRPr>
             </a:pPr>
@@ -12946,11 +12946,11 @@
             <a:avLst/>
           </a:prstGeom>
           <a:solidFill>
-            <a:srgbClr val="163451"/>
+            <a:srgbClr val="E8E3D8"/>
           </a:solidFill>
           <a:ln>
             <a:solidFill>
-              <a:srgbClr val="55A7FF"/>
+              <a:srgbClr val="176B87"/>
             </a:solidFill>
           </a:ln>
         </p:spPr>
@@ -12975,7 +12975,7 @@
             <a:pPr algn="ctr">
               <a:defRPr sz="1100" b="1">
                 <a:solidFill>
-                  <a:srgbClr val="F4F8FC"/>
+                  <a:srgbClr val="151515"/>
                 </a:solidFill>
               </a:defRPr>
             </a:pPr>
@@ -13010,7 +13010,7 @@
             <a:pPr algn="ctr">
               <a:defRPr sz="1100">
                 <a:solidFill>
-                  <a:srgbClr val="46D6C8"/>
+                  <a:srgbClr val="E6462E"/>
                 </a:solidFill>
               </a:defRPr>
             </a:pPr>
@@ -13035,11 +13035,11 @@
             <a:avLst/>
           </a:prstGeom>
           <a:solidFill>
-            <a:srgbClr val="163451"/>
+            <a:srgbClr val="E8E3D8"/>
           </a:solidFill>
           <a:ln>
             <a:solidFill>
-              <a:srgbClr val="55A7FF"/>
+              <a:srgbClr val="176B87"/>
             </a:solidFill>
           </a:ln>
         </p:spPr>
@@ -13064,7 +13064,7 @@
             <a:pPr algn="ctr">
               <a:defRPr sz="1100" b="1">
                 <a:solidFill>
-                  <a:srgbClr val="F4F8FC"/>
+                  <a:srgbClr val="151515"/>
                 </a:solidFill>
               </a:defRPr>
             </a:pPr>
@@ -13089,11 +13089,11 @@
             <a:avLst/>
           </a:prstGeom>
           <a:solidFill>
-            <a:srgbClr val="163451"/>
+            <a:srgbClr val="E8E3D8"/>
           </a:solidFill>
           <a:ln>
             <a:solidFill>
-              <a:srgbClr val="55A7FF"/>
+              <a:srgbClr val="176B87"/>
             </a:solidFill>
           </a:ln>
         </p:spPr>
@@ -13118,7 +13118,7 @@
             <a:pPr algn="ctr">
               <a:defRPr sz="1100" b="1">
                 <a:solidFill>
-                  <a:srgbClr val="F4F8FC"/>
+                  <a:srgbClr val="151515"/>
                 </a:solidFill>
               </a:defRPr>
             </a:pPr>
@@ -13153,7 +13153,7 @@
             <a:pPr algn="ctr">
               <a:defRPr sz="1100">
                 <a:solidFill>
-                  <a:srgbClr val="46D6C8"/>
+                  <a:srgbClr val="E6462E"/>
                 </a:solidFill>
               </a:defRPr>
             </a:pPr>
@@ -13178,11 +13178,11 @@
             <a:avLst/>
           </a:prstGeom>
           <a:solidFill>
-            <a:srgbClr val="163451"/>
+            <a:srgbClr val="E8E3D8"/>
           </a:solidFill>
           <a:ln>
             <a:solidFill>
-              <a:srgbClr val="55A7FF"/>
+              <a:srgbClr val="176B87"/>
             </a:solidFill>
           </a:ln>
         </p:spPr>
@@ -13207,7 +13207,7 @@
             <a:pPr algn="ctr">
               <a:defRPr sz="1100" b="1">
                 <a:solidFill>
-                  <a:srgbClr val="F4F8FC"/>
+                  <a:srgbClr val="151515"/>
                 </a:solidFill>
               </a:defRPr>
             </a:pPr>
@@ -13232,11 +13232,11 @@
             <a:avLst/>
           </a:prstGeom>
           <a:solidFill>
-            <a:srgbClr val="163451"/>
+            <a:srgbClr val="E8E3D8"/>
           </a:solidFill>
           <a:ln>
             <a:solidFill>
-              <a:srgbClr val="55A7FF"/>
+              <a:srgbClr val="176B87"/>
             </a:solidFill>
           </a:ln>
         </p:spPr>
@@ -13261,7 +13261,7 @@
             <a:pPr algn="ctr">
               <a:defRPr sz="1100" b="1">
                 <a:solidFill>
-                  <a:srgbClr val="F4F8FC"/>
+                  <a:srgbClr val="151515"/>
                 </a:solidFill>
               </a:defRPr>
             </a:pPr>
@@ -13296,7 +13296,7 @@
             <a:pPr algn="ctr">
               <a:defRPr sz="1100">
                 <a:solidFill>
-                  <a:srgbClr val="46D6C8"/>
+                  <a:srgbClr val="E6462E"/>
                 </a:solidFill>
               </a:defRPr>
             </a:pPr>
@@ -13321,11 +13321,11 @@
             <a:avLst/>
           </a:prstGeom>
           <a:solidFill>
-            <a:srgbClr val="163451"/>
+            <a:srgbClr val="E8E3D8"/>
           </a:solidFill>
           <a:ln>
             <a:solidFill>
-              <a:srgbClr val="55A7FF"/>
+              <a:srgbClr val="176B87"/>
             </a:solidFill>
           </a:ln>
         </p:spPr>
@@ -13350,7 +13350,7 @@
             <a:pPr algn="ctr">
               <a:defRPr sz="1100" b="1">
                 <a:solidFill>
-                  <a:srgbClr val="F4F8FC"/>
+                  <a:srgbClr val="151515"/>
                 </a:solidFill>
               </a:defRPr>
             </a:pPr>
@@ -13375,11 +13375,11 @@
             <a:avLst/>
           </a:prstGeom>
           <a:solidFill>
-            <a:srgbClr val="163451"/>
+            <a:srgbClr val="E8E3D8"/>
           </a:solidFill>
           <a:ln>
             <a:solidFill>
-              <a:srgbClr val="55A7FF"/>
+              <a:srgbClr val="176B87"/>
             </a:solidFill>
           </a:ln>
         </p:spPr>
@@ -13404,7 +13404,7 @@
             <a:pPr algn="ctr">
               <a:defRPr sz="1100" b="1">
                 <a:solidFill>
-                  <a:srgbClr val="F4F8FC"/>
+                  <a:srgbClr val="151515"/>
                 </a:solidFill>
               </a:defRPr>
             </a:pPr>
@@ -13439,7 +13439,7 @@
             <a:pPr algn="ctr">
               <a:defRPr sz="1100">
                 <a:solidFill>
-                  <a:srgbClr val="46D6C8"/>
+                  <a:srgbClr val="E6462E"/>
                 </a:solidFill>
               </a:defRPr>
             </a:pPr>
@@ -13474,7 +13474,7 @@
             <a:pPr>
               <a:defRPr sz="900">
                 <a:solidFill>
-                  <a:srgbClr val="9AB2C8"/>
+                  <a:srgbClr val="62666A"/>
                 </a:solidFill>
               </a:defRPr>
             </a:pPr>
@@ -13498,7 +13498,7 @@
     <p:bg>
       <p:bgPr>
         <a:solidFill>
-          <a:srgbClr val="07111F"/>
+          <a:srgbClr val="F4F1E8"/>
         </a:solidFill>
         <a:effectLst/>
       </p:bgPr>
@@ -13525,7 +13525,7 @@
             <a:avLst/>
           </a:prstGeom>
           <a:solidFill>
-            <a:srgbClr val="46D6C8"/>
+            <a:srgbClr val="E6462E"/>
           </a:solidFill>
           <a:ln>
             <a:noFill/>
@@ -13578,7 +13578,7 @@
             <a:pPr>
               <a:defRPr sz="900" b="1">
                 <a:solidFill>
-                  <a:srgbClr val="46D6C8"/>
+                  <a:srgbClr val="E6462E"/>
                 </a:solidFill>
               </a:defRPr>
             </a:pPr>
@@ -13613,7 +13613,7 @@
             <a:pPr algn="l">
               <a:defRPr sz="2700" b="1">
                 <a:solidFill>
-                  <a:srgbClr val="F4F8FC"/>
+                  <a:srgbClr val="151515"/>
                 </a:solidFill>
               </a:defRPr>
             </a:pPr>
@@ -13638,7 +13638,7 @@
             <a:avLst/>
           </a:prstGeom>
           <a:solidFill>
-            <a:srgbClr val="10243C"/>
+            <a:srgbClr val="FFFFFF"/>
           </a:solidFill>
           <a:ln>
             <a:solidFill>
@@ -13667,7 +13667,7 @@
             <a:pPr algn="ctr">
               <a:defRPr sz="1200" b="1">
                 <a:solidFill>
-                  <a:srgbClr val="46D6C8"/>
+                  <a:srgbClr val="E6462E"/>
                 </a:solidFill>
               </a:defRPr>
             </a:pPr>
@@ -13682,7 +13682,7 @@
               </a:spcBef>
               <a:defRPr sz="1500">
                 <a:solidFill>
-                  <a:srgbClr val="F4F8FC"/>
+                  <a:srgbClr val="151515"/>
                 </a:solidFill>
               </a:defRPr>
             </a:pPr>
@@ -13707,7 +13707,7 @@
             <a:avLst/>
           </a:prstGeom>
           <a:solidFill>
-            <a:srgbClr val="46D6C8"/>
+            <a:srgbClr val="E6462E"/>
           </a:solidFill>
           <a:ln>
             <a:noFill/>
@@ -13750,7 +13750,7 @@
             <a:avLst/>
           </a:prstGeom>
           <a:solidFill>
-            <a:srgbClr val="10243C"/>
+            <a:srgbClr val="FFFFFF"/>
           </a:solidFill>
           <a:ln>
             <a:solidFill>
@@ -13779,7 +13779,7 @@
             <a:pPr algn="ctr">
               <a:defRPr sz="1200" b="1">
                 <a:solidFill>
-                  <a:srgbClr val="55A7FF"/>
+                  <a:srgbClr val="176B87"/>
                 </a:solidFill>
               </a:defRPr>
             </a:pPr>
@@ -13794,7 +13794,7 @@
               </a:spcBef>
               <a:defRPr sz="1500">
                 <a:solidFill>
-                  <a:srgbClr val="F4F8FC"/>
+                  <a:srgbClr val="151515"/>
                 </a:solidFill>
               </a:defRPr>
             </a:pPr>
@@ -13819,7 +13819,7 @@
             <a:avLst/>
           </a:prstGeom>
           <a:solidFill>
-            <a:srgbClr val="55A7FF"/>
+            <a:srgbClr val="176B87"/>
           </a:solidFill>
           <a:ln>
             <a:noFill/>
@@ -13862,7 +13862,7 @@
             <a:avLst/>
           </a:prstGeom>
           <a:solidFill>
-            <a:srgbClr val="10243C"/>
+            <a:srgbClr val="FFFFFF"/>
           </a:solidFill>
           <a:ln>
             <a:solidFill>
@@ -13891,7 +13891,7 @@
             <a:pPr algn="ctr">
               <a:defRPr sz="1200" b="1">
                 <a:solidFill>
-                  <a:srgbClr val="FFBE55"/>
+                  <a:srgbClr val="D39A28"/>
                 </a:solidFill>
               </a:defRPr>
             </a:pPr>
@@ -13906,7 +13906,7 @@
               </a:spcBef>
               <a:defRPr sz="1500">
                 <a:solidFill>
-                  <a:srgbClr val="F4F8FC"/>
+                  <a:srgbClr val="151515"/>
                 </a:solidFill>
               </a:defRPr>
             </a:pPr>
@@ -13931,7 +13931,7 @@
             <a:avLst/>
           </a:prstGeom>
           <a:solidFill>
-            <a:srgbClr val="FFBE55"/>
+            <a:srgbClr val="D39A28"/>
           </a:solidFill>
           <a:ln>
             <a:noFill/>
@@ -13974,7 +13974,7 @@
             <a:avLst/>
           </a:prstGeom>
           <a:solidFill>
-            <a:srgbClr val="10243C"/>
+            <a:srgbClr val="FFFFFF"/>
           </a:solidFill>
           <a:ln>
             <a:solidFill>
@@ -14003,7 +14003,7 @@
             <a:pPr algn="ctr">
               <a:defRPr sz="1200" b="1">
                 <a:solidFill>
-                  <a:srgbClr val="46D6C8"/>
+                  <a:srgbClr val="E6462E"/>
                 </a:solidFill>
               </a:defRPr>
             </a:pPr>
@@ -14018,7 +14018,7 @@
               </a:spcBef>
               <a:defRPr sz="1500">
                 <a:solidFill>
-                  <a:srgbClr val="F4F8FC"/>
+                  <a:srgbClr val="151515"/>
                 </a:solidFill>
               </a:defRPr>
             </a:pPr>
@@ -14043,7 +14043,7 @@
             <a:avLst/>
           </a:prstGeom>
           <a:solidFill>
-            <a:srgbClr val="46D6C8"/>
+            <a:srgbClr val="E6462E"/>
           </a:solidFill>
           <a:ln>
             <a:noFill/>
@@ -14086,7 +14086,7 @@
             <a:avLst/>
           </a:prstGeom>
           <a:solidFill>
-            <a:srgbClr val="10243C"/>
+            <a:srgbClr val="FFFFFF"/>
           </a:solidFill>
           <a:ln>
             <a:solidFill>
@@ -14115,7 +14115,7 @@
             <a:pPr algn="ctr">
               <a:defRPr sz="1200" b="1">
                 <a:solidFill>
-                  <a:srgbClr val="55A7FF"/>
+                  <a:srgbClr val="176B87"/>
                 </a:solidFill>
               </a:defRPr>
             </a:pPr>
@@ -14130,7 +14130,7 @@
               </a:spcBef>
               <a:defRPr sz="1500">
                 <a:solidFill>
-                  <a:srgbClr val="F4F8FC"/>
+                  <a:srgbClr val="151515"/>
                 </a:solidFill>
               </a:defRPr>
             </a:pPr>
@@ -14155,7 +14155,7 @@
             <a:avLst/>
           </a:prstGeom>
           <a:solidFill>
-            <a:srgbClr val="55A7FF"/>
+            <a:srgbClr val="176B87"/>
           </a:solidFill>
           <a:ln>
             <a:noFill/>
@@ -14198,7 +14198,7 @@
             <a:avLst/>
           </a:prstGeom>
           <a:solidFill>
-            <a:srgbClr val="10243C"/>
+            <a:srgbClr val="FFFFFF"/>
           </a:solidFill>
           <a:ln>
             <a:solidFill>
@@ -14227,7 +14227,7 @@
             <a:pPr algn="ctr">
               <a:defRPr sz="1200" b="1">
                 <a:solidFill>
-                  <a:srgbClr val="FFBE55"/>
+                  <a:srgbClr val="D39A28"/>
                 </a:solidFill>
               </a:defRPr>
             </a:pPr>
@@ -14242,7 +14242,7 @@
               </a:spcBef>
               <a:defRPr sz="1500">
                 <a:solidFill>
-                  <a:srgbClr val="F4F8FC"/>
+                  <a:srgbClr val="151515"/>
                 </a:solidFill>
               </a:defRPr>
             </a:pPr>
@@ -14267,7 +14267,7 @@
             <a:avLst/>
           </a:prstGeom>
           <a:solidFill>
-            <a:srgbClr val="FFBE55"/>
+            <a:srgbClr val="D39A28"/>
           </a:solidFill>
           <a:ln>
             <a:noFill/>
@@ -14320,7 +14320,7 @@
             <a:pPr>
               <a:defRPr sz="900">
                 <a:solidFill>
-                  <a:srgbClr val="9AB2C8"/>
+                  <a:srgbClr val="62666A"/>
                 </a:solidFill>
               </a:defRPr>
             </a:pPr>
@@ -14344,7 +14344,7 @@
     <p:bg>
       <p:bgPr>
         <a:solidFill>
-          <a:srgbClr val="07111F"/>
+          <a:srgbClr val="F4F1E8"/>
         </a:solidFill>
         <a:effectLst/>
       </p:bgPr>
@@ -14371,7 +14371,7 @@
             <a:avLst/>
           </a:prstGeom>
           <a:solidFill>
-            <a:srgbClr val="46D6C8"/>
+            <a:srgbClr val="E6462E"/>
           </a:solidFill>
           <a:ln>
             <a:noFill/>
@@ -14424,7 +14424,7 @@
             <a:pPr>
               <a:defRPr sz="900" b="1">
                 <a:solidFill>
-                  <a:srgbClr val="46D6C8"/>
+                  <a:srgbClr val="E6462E"/>
                 </a:solidFill>
               </a:defRPr>
             </a:pPr>
@@ -14459,7 +14459,7 @@
             <a:pPr algn="l">
               <a:defRPr sz="2700" b="1">
                 <a:solidFill>
-                  <a:srgbClr val="F4F8FC"/>
+                  <a:srgbClr val="151515"/>
                 </a:solidFill>
               </a:defRPr>
             </a:pPr>
@@ -14484,7 +14484,7 @@
             <a:avLst/>
           </a:prstGeom>
           <a:solidFill>
-            <a:srgbClr val="10243C"/>
+            <a:srgbClr val="FFFFFF"/>
           </a:solidFill>
           <a:ln>
             <a:solidFill>
@@ -14513,7 +14513,7 @@
             <a:pPr algn="ctr">
               <a:defRPr sz="3000" b="1">
                 <a:solidFill>
-                  <a:srgbClr val="46D6C8"/>
+                  <a:srgbClr val="E6462E"/>
                 </a:solidFill>
               </a:defRPr>
             </a:pPr>
@@ -14528,7 +14528,7 @@
               </a:spcBef>
               <a:defRPr sz="1200">
                 <a:solidFill>
-                  <a:srgbClr val="9AB2C8"/>
+                  <a:srgbClr val="62666A"/>
                 </a:solidFill>
               </a:defRPr>
             </a:pPr>
@@ -14553,7 +14553,7 @@
             <a:avLst/>
           </a:prstGeom>
           <a:solidFill>
-            <a:srgbClr val="10243C"/>
+            <a:srgbClr val="FFFFFF"/>
           </a:solidFill>
           <a:ln>
             <a:solidFill>
@@ -14582,7 +14582,7 @@
             <a:pPr algn="ctr">
               <a:defRPr sz="3000" b="1">
                 <a:solidFill>
-                  <a:srgbClr val="46D6C8"/>
+                  <a:srgbClr val="E6462E"/>
                 </a:solidFill>
               </a:defRPr>
             </a:pPr>
@@ -14597,7 +14597,7 @@
               </a:spcBef>
               <a:defRPr sz="1200">
                 <a:solidFill>
-                  <a:srgbClr val="9AB2C8"/>
+                  <a:srgbClr val="62666A"/>
                 </a:solidFill>
               </a:defRPr>
             </a:pPr>
@@ -14622,7 +14622,7 @@
             <a:avLst/>
           </a:prstGeom>
           <a:solidFill>
-            <a:srgbClr val="10243C"/>
+            <a:srgbClr val="FFFFFF"/>
           </a:solidFill>
           <a:ln>
             <a:solidFill>
@@ -14651,7 +14651,7 @@
             <a:pPr algn="ctr">
               <a:defRPr sz="3000" b="1">
                 <a:solidFill>
-                  <a:srgbClr val="46D6C8"/>
+                  <a:srgbClr val="E6462E"/>
                 </a:solidFill>
               </a:defRPr>
             </a:pPr>
@@ -14666,7 +14666,7 @@
               </a:spcBef>
               <a:defRPr sz="1200">
                 <a:solidFill>
-                  <a:srgbClr val="9AB2C8"/>
+                  <a:srgbClr val="62666A"/>
                 </a:solidFill>
               </a:defRPr>
             </a:pPr>
@@ -14691,7 +14691,7 @@
             <a:avLst/>
           </a:prstGeom>
           <a:solidFill>
-            <a:srgbClr val="10243C"/>
+            <a:srgbClr val="FFFFFF"/>
           </a:solidFill>
           <a:ln>
             <a:solidFill>
@@ -14720,7 +14720,7 @@
             <a:pPr algn="ctr">
               <a:defRPr sz="3000" b="1">
                 <a:solidFill>
-                  <a:srgbClr val="46D6C8"/>
+                  <a:srgbClr val="E6462E"/>
                 </a:solidFill>
               </a:defRPr>
             </a:pPr>
@@ -14735,7 +14735,7 @@
               </a:spcBef>
               <a:defRPr sz="1200">
                 <a:solidFill>
-                  <a:srgbClr val="9AB2C8"/>
+                  <a:srgbClr val="62666A"/>
                 </a:solidFill>
               </a:defRPr>
             </a:pPr>
@@ -14760,7 +14760,7 @@
             <a:avLst/>
           </a:prstGeom>
           <a:solidFill>
-            <a:srgbClr val="10243C"/>
+            <a:srgbClr val="FFFFFF"/>
           </a:solidFill>
           <a:ln>
             <a:solidFill>
@@ -14789,7 +14789,7 @@
             <a:pPr algn="ctr">
               <a:defRPr sz="3000" b="1">
                 <a:solidFill>
-                  <a:srgbClr val="46D6C8"/>
+                  <a:srgbClr val="E6462E"/>
                 </a:solidFill>
               </a:defRPr>
             </a:pPr>
@@ -14804,7 +14804,7 @@
               </a:spcBef>
               <a:defRPr sz="1200">
                 <a:solidFill>
-                  <a:srgbClr val="9AB2C8"/>
+                  <a:srgbClr val="62666A"/>
                 </a:solidFill>
               </a:defRPr>
             </a:pPr>
@@ -14829,7 +14829,7 @@
             <a:avLst/>
           </a:prstGeom>
           <a:solidFill>
-            <a:srgbClr val="10243C"/>
+            <a:srgbClr val="FFFFFF"/>
           </a:solidFill>
           <a:ln>
             <a:solidFill>
@@ -14858,7 +14858,7 @@
             <a:pPr algn="ctr">
               <a:defRPr sz="3000" b="1">
                 <a:solidFill>
-                  <a:srgbClr val="46D6C8"/>
+                  <a:srgbClr val="E6462E"/>
                 </a:solidFill>
               </a:defRPr>
             </a:pPr>
@@ -14873,7 +14873,7 @@
               </a:spcBef>
               <a:defRPr sz="1200">
                 <a:solidFill>
-                  <a:srgbClr val="9AB2C8"/>
+                  <a:srgbClr val="62666A"/>
                 </a:solidFill>
               </a:defRPr>
             </a:pPr>
@@ -14908,7 +14908,7 @@
             <a:pPr>
               <a:defRPr sz="900">
                 <a:solidFill>
-                  <a:srgbClr val="9AB2C8"/>
+                  <a:srgbClr val="62666A"/>
                 </a:solidFill>
               </a:defRPr>
             </a:pPr>
@@ -14932,7 +14932,7 @@
     <p:bg>
       <p:bgPr>
         <a:solidFill>
-          <a:srgbClr val="07111F"/>
+          <a:srgbClr val="F4F1E8"/>
         </a:solidFill>
         <a:effectLst/>
       </p:bgPr>
@@ -14959,7 +14959,7 @@
             <a:avLst/>
           </a:prstGeom>
           <a:solidFill>
-            <a:srgbClr val="46D6C8"/>
+            <a:srgbClr val="E6462E"/>
           </a:solidFill>
           <a:ln>
             <a:noFill/>
@@ -15012,7 +15012,7 @@
             <a:pPr>
               <a:defRPr sz="900" b="1">
                 <a:solidFill>
-                  <a:srgbClr val="46D6C8"/>
+                  <a:srgbClr val="E6462E"/>
                 </a:solidFill>
               </a:defRPr>
             </a:pPr>
@@ -15047,7 +15047,7 @@
             <a:pPr algn="l">
               <a:defRPr sz="2700" b="1">
                 <a:solidFill>
-                  <a:srgbClr val="F4F8FC"/>
+                  <a:srgbClr val="151515"/>
                 </a:solidFill>
               </a:defRPr>
             </a:pPr>
@@ -15072,7 +15072,7 @@
             <a:avLst/>
           </a:prstGeom>
           <a:solidFill>
-            <a:srgbClr val="10243C"/>
+            <a:srgbClr val="FFFFFF"/>
           </a:solidFill>
           <a:ln>
             <a:solidFill>
@@ -15101,7 +15101,7 @@
             <a:pPr algn="ctr">
               <a:defRPr sz="1200" b="1">
                 <a:solidFill>
-                  <a:srgbClr val="46D6C8"/>
+                  <a:srgbClr val="E6462E"/>
                 </a:solidFill>
               </a:defRPr>
             </a:pPr>
@@ -15116,7 +15116,7 @@
               </a:spcBef>
               <a:defRPr sz="1500">
                 <a:solidFill>
-                  <a:srgbClr val="F4F8FC"/>
+                  <a:srgbClr val="151515"/>
                 </a:solidFill>
               </a:defRPr>
             </a:pPr>
@@ -15141,7 +15141,7 @@
             <a:avLst/>
           </a:prstGeom>
           <a:solidFill>
-            <a:srgbClr val="46D6C8"/>
+            <a:srgbClr val="E6462E"/>
           </a:solidFill>
           <a:ln>
             <a:noFill/>
@@ -15184,7 +15184,7 @@
             <a:avLst/>
           </a:prstGeom>
           <a:solidFill>
-            <a:srgbClr val="10243C"/>
+            <a:srgbClr val="FFFFFF"/>
           </a:solidFill>
           <a:ln>
             <a:solidFill>
@@ -15213,7 +15213,7 @@
             <a:pPr algn="ctr">
               <a:defRPr sz="1200" b="1">
                 <a:solidFill>
-                  <a:srgbClr val="55A7FF"/>
+                  <a:srgbClr val="176B87"/>
                 </a:solidFill>
               </a:defRPr>
             </a:pPr>
@@ -15228,7 +15228,7 @@
               </a:spcBef>
               <a:defRPr sz="1500">
                 <a:solidFill>
-                  <a:srgbClr val="F4F8FC"/>
+                  <a:srgbClr val="151515"/>
                 </a:solidFill>
               </a:defRPr>
             </a:pPr>
@@ -15253,7 +15253,7 @@
             <a:avLst/>
           </a:prstGeom>
           <a:solidFill>
-            <a:srgbClr val="55A7FF"/>
+            <a:srgbClr val="176B87"/>
           </a:solidFill>
           <a:ln>
             <a:noFill/>
@@ -15296,7 +15296,7 @@
             <a:avLst/>
           </a:prstGeom>
           <a:solidFill>
-            <a:srgbClr val="10243C"/>
+            <a:srgbClr val="FFFFFF"/>
           </a:solidFill>
           <a:ln>
             <a:solidFill>
@@ -15325,7 +15325,7 @@
             <a:pPr algn="ctr">
               <a:defRPr sz="1200" b="1">
                 <a:solidFill>
-                  <a:srgbClr val="FFBE55"/>
+                  <a:srgbClr val="D39A28"/>
                 </a:solidFill>
               </a:defRPr>
             </a:pPr>
@@ -15340,7 +15340,7 @@
               </a:spcBef>
               <a:defRPr sz="1500">
                 <a:solidFill>
-                  <a:srgbClr val="F4F8FC"/>
+                  <a:srgbClr val="151515"/>
                 </a:solidFill>
               </a:defRPr>
             </a:pPr>
@@ -15365,7 +15365,7 @@
             <a:avLst/>
           </a:prstGeom>
           <a:solidFill>
-            <a:srgbClr val="FFBE55"/>
+            <a:srgbClr val="D39A28"/>
           </a:solidFill>
           <a:ln>
             <a:noFill/>
@@ -15408,7 +15408,7 @@
             <a:avLst/>
           </a:prstGeom>
           <a:solidFill>
-            <a:srgbClr val="10243C"/>
+            <a:srgbClr val="FFFFFF"/>
           </a:solidFill>
           <a:ln>
             <a:solidFill>
@@ -15437,7 +15437,7 @@
             <a:pPr algn="ctr">
               <a:defRPr sz="1200" b="1">
                 <a:solidFill>
-                  <a:srgbClr val="46D6C8"/>
+                  <a:srgbClr val="E6462E"/>
                 </a:solidFill>
               </a:defRPr>
             </a:pPr>
@@ -15452,7 +15452,7 @@
               </a:spcBef>
               <a:defRPr sz="1500">
                 <a:solidFill>
-                  <a:srgbClr val="F4F8FC"/>
+                  <a:srgbClr val="151515"/>
                 </a:solidFill>
               </a:defRPr>
             </a:pPr>
@@ -15477,7 +15477,7 @@
             <a:avLst/>
           </a:prstGeom>
           <a:solidFill>
-            <a:srgbClr val="46D6C8"/>
+            <a:srgbClr val="E6462E"/>
           </a:solidFill>
           <a:ln>
             <a:noFill/>
@@ -15520,7 +15520,7 @@
             <a:avLst/>
           </a:prstGeom>
           <a:solidFill>
-            <a:srgbClr val="10243C"/>
+            <a:srgbClr val="FFFFFF"/>
           </a:solidFill>
           <a:ln>
             <a:solidFill>
@@ -15549,7 +15549,7 @@
             <a:pPr algn="ctr">
               <a:defRPr sz="1200" b="1">
                 <a:solidFill>
-                  <a:srgbClr val="55A7FF"/>
+                  <a:srgbClr val="176B87"/>
                 </a:solidFill>
               </a:defRPr>
             </a:pPr>
@@ -15564,7 +15564,7 @@
               </a:spcBef>
               <a:defRPr sz="1100">
                 <a:solidFill>
-                  <a:srgbClr val="F4F8FC"/>
+                  <a:srgbClr val="151515"/>
                 </a:solidFill>
               </a:defRPr>
             </a:pPr>
@@ -15589,7 +15589,7 @@
             <a:avLst/>
           </a:prstGeom>
           <a:solidFill>
-            <a:srgbClr val="55A7FF"/>
+            <a:srgbClr val="176B87"/>
           </a:solidFill>
           <a:ln>
             <a:noFill/>
@@ -15642,7 +15642,7 @@
             <a:pPr>
               <a:defRPr sz="900">
                 <a:solidFill>
-                  <a:srgbClr val="9AB2C8"/>
+                  <a:srgbClr val="62666A"/>
                 </a:solidFill>
               </a:defRPr>
             </a:pPr>
@@ -15666,7 +15666,7 @@
     <p:bg>
       <p:bgPr>
         <a:solidFill>
-          <a:srgbClr val="07111F"/>
+          <a:srgbClr val="F4F1E8"/>
         </a:solidFill>
         <a:effectLst/>
       </p:bgPr>
@@ -15693,7 +15693,7 @@
             <a:avLst/>
           </a:prstGeom>
           <a:solidFill>
-            <a:srgbClr val="46D6C8"/>
+            <a:srgbClr val="E6462E"/>
           </a:solidFill>
           <a:ln>
             <a:noFill/>
@@ -15746,7 +15746,7 @@
             <a:pPr>
               <a:defRPr sz="900" b="1">
                 <a:solidFill>
-                  <a:srgbClr val="46D6C8"/>
+                  <a:srgbClr val="E6462E"/>
                 </a:solidFill>
               </a:defRPr>
             </a:pPr>
@@ -15781,7 +15781,7 @@
             <a:pPr algn="l">
               <a:defRPr sz="2700" b="1">
                 <a:solidFill>
-                  <a:srgbClr val="F4F8FC"/>
+                  <a:srgbClr val="151515"/>
                 </a:solidFill>
               </a:defRPr>
             </a:pPr>
@@ -15806,7 +15806,7 @@
             <a:avLst/>
           </a:prstGeom>
           <a:solidFill>
-            <a:srgbClr val="10243C"/>
+            <a:srgbClr val="FFFFFF"/>
           </a:solidFill>
           <a:ln>
             <a:solidFill>
@@ -15835,7 +15835,7 @@
             <a:pPr algn="ctr">
               <a:defRPr sz="1200" b="1">
                 <a:solidFill>
-                  <a:srgbClr val="46D6C8"/>
+                  <a:srgbClr val="E6462E"/>
                 </a:solidFill>
               </a:defRPr>
             </a:pPr>
@@ -15850,7 +15850,7 @@
               </a:spcBef>
               <a:defRPr sz="1100">
                 <a:solidFill>
-                  <a:srgbClr val="F4F8FC"/>
+                  <a:srgbClr val="151515"/>
                 </a:solidFill>
               </a:defRPr>
             </a:pPr>
@@ -15875,7 +15875,7 @@
             <a:avLst/>
           </a:prstGeom>
           <a:solidFill>
-            <a:srgbClr val="46D6C8"/>
+            <a:srgbClr val="E6462E"/>
           </a:solidFill>
           <a:ln>
             <a:noFill/>
@@ -15918,7 +15918,7 @@
             <a:avLst/>
           </a:prstGeom>
           <a:solidFill>
-            <a:srgbClr val="10243C"/>
+            <a:srgbClr val="FFFFFF"/>
           </a:solidFill>
           <a:ln>
             <a:solidFill>
@@ -15947,7 +15947,7 @@
             <a:pPr algn="ctr">
               <a:defRPr sz="1200" b="1">
                 <a:solidFill>
-                  <a:srgbClr val="55A7FF"/>
+                  <a:srgbClr val="176B87"/>
                 </a:solidFill>
               </a:defRPr>
             </a:pPr>
@@ -15962,7 +15962,7 @@
               </a:spcBef>
               <a:defRPr sz="1100">
                 <a:solidFill>
-                  <a:srgbClr val="F4F8FC"/>
+                  <a:srgbClr val="151515"/>
                 </a:solidFill>
               </a:defRPr>
             </a:pPr>
@@ -15987,7 +15987,7 @@
             <a:avLst/>
           </a:prstGeom>
           <a:solidFill>
-            <a:srgbClr val="55A7FF"/>
+            <a:srgbClr val="176B87"/>
           </a:solidFill>
           <a:ln>
             <a:noFill/>
@@ -16030,7 +16030,7 @@
             <a:avLst/>
           </a:prstGeom>
           <a:solidFill>
-            <a:srgbClr val="10243C"/>
+            <a:srgbClr val="FFFFFF"/>
           </a:solidFill>
           <a:ln>
             <a:solidFill>
@@ -16059,7 +16059,7 @@
             <a:pPr algn="ctr">
               <a:defRPr sz="1200" b="1">
                 <a:solidFill>
-                  <a:srgbClr val="FFBE55"/>
+                  <a:srgbClr val="D39A28"/>
                 </a:solidFill>
               </a:defRPr>
             </a:pPr>
@@ -16074,7 +16074,7 @@
               </a:spcBef>
               <a:defRPr sz="1100">
                 <a:solidFill>
-                  <a:srgbClr val="F4F8FC"/>
+                  <a:srgbClr val="151515"/>
                 </a:solidFill>
               </a:defRPr>
             </a:pPr>
@@ -16099,7 +16099,7 @@
             <a:avLst/>
           </a:prstGeom>
           <a:solidFill>
-            <a:srgbClr val="FFBE55"/>
+            <a:srgbClr val="D39A28"/>
           </a:solidFill>
           <a:ln>
             <a:noFill/>
@@ -16142,7 +16142,7 @@
             <a:avLst/>
           </a:prstGeom>
           <a:solidFill>
-            <a:srgbClr val="10243C"/>
+            <a:srgbClr val="FFFFFF"/>
           </a:solidFill>
           <a:ln>
             <a:solidFill>
@@ -16171,7 +16171,7 @@
             <a:pPr algn="ctr">
               <a:defRPr sz="1200" b="1">
                 <a:solidFill>
-                  <a:srgbClr val="46D6C8"/>
+                  <a:srgbClr val="E6462E"/>
                 </a:solidFill>
               </a:defRPr>
             </a:pPr>
@@ -16186,7 +16186,7 @@
               </a:spcBef>
               <a:defRPr sz="1100">
                 <a:solidFill>
-                  <a:srgbClr val="F4F8FC"/>
+                  <a:srgbClr val="151515"/>
                 </a:solidFill>
               </a:defRPr>
             </a:pPr>
@@ -16211,7 +16211,7 @@
             <a:avLst/>
           </a:prstGeom>
           <a:solidFill>
-            <a:srgbClr val="46D6C8"/>
+            <a:srgbClr val="E6462E"/>
           </a:solidFill>
           <a:ln>
             <a:noFill/>
@@ -16254,7 +16254,7 @@
             <a:avLst/>
           </a:prstGeom>
           <a:solidFill>
-            <a:srgbClr val="10243C"/>
+            <a:srgbClr val="FFFFFF"/>
           </a:solidFill>
           <a:ln>
             <a:solidFill>
@@ -16283,7 +16283,7 @@
             <a:pPr algn="ctr">
               <a:defRPr sz="1200" b="1">
                 <a:solidFill>
-                  <a:srgbClr val="55A7FF"/>
+                  <a:srgbClr val="176B87"/>
                 </a:solidFill>
               </a:defRPr>
             </a:pPr>
@@ -16298,7 +16298,7 @@
               </a:spcBef>
               <a:defRPr sz="1100">
                 <a:solidFill>
-                  <a:srgbClr val="F4F8FC"/>
+                  <a:srgbClr val="151515"/>
                 </a:solidFill>
               </a:defRPr>
             </a:pPr>
@@ -16323,7 +16323,7 @@
             <a:avLst/>
           </a:prstGeom>
           <a:solidFill>
-            <a:srgbClr val="55A7FF"/>
+            <a:srgbClr val="176B87"/>
           </a:solidFill>
           <a:ln>
             <a:noFill/>
@@ -16376,7 +16376,7 @@
             <a:pPr>
               <a:defRPr sz="900">
                 <a:solidFill>
-                  <a:srgbClr val="9AB2C8"/>
+                  <a:srgbClr val="62666A"/>
                 </a:solidFill>
               </a:defRPr>
             </a:pPr>
@@ -16400,7 +16400,7 @@
     <p:bg>
       <p:bgPr>
         <a:solidFill>
-          <a:srgbClr val="07111F"/>
+          <a:srgbClr val="F4F1E8"/>
         </a:solidFill>
         <a:effectLst/>
       </p:bgPr>
@@ -16427,7 +16427,7 @@
             <a:avLst/>
           </a:prstGeom>
           <a:solidFill>
-            <a:srgbClr val="46D6C8"/>
+            <a:srgbClr val="E6462E"/>
           </a:solidFill>
           <a:ln>
             <a:noFill/>
@@ -16480,7 +16480,7 @@
             <a:pPr>
               <a:defRPr sz="900" b="1">
                 <a:solidFill>
-                  <a:srgbClr val="46D6C8"/>
+                  <a:srgbClr val="E6462E"/>
                 </a:solidFill>
               </a:defRPr>
             </a:pPr>
@@ -16515,7 +16515,7 @@
             <a:pPr algn="l">
               <a:defRPr sz="2700" b="1">
                 <a:solidFill>
-                  <a:srgbClr val="F4F8FC"/>
+                  <a:srgbClr val="151515"/>
                 </a:solidFill>
               </a:defRPr>
             </a:pPr>
@@ -16540,7 +16540,7 @@
             <a:avLst/>
           </a:prstGeom>
           <a:solidFill>
-            <a:srgbClr val="10243C"/>
+            <a:srgbClr val="FFFFFF"/>
           </a:solidFill>
           <a:ln>
             <a:solidFill>
@@ -16569,7 +16569,7 @@
             <a:pPr algn="ctr">
               <a:defRPr sz="1200" b="1">
                 <a:solidFill>
-                  <a:srgbClr val="46D6C8"/>
+                  <a:srgbClr val="E6462E"/>
                 </a:solidFill>
               </a:defRPr>
             </a:pPr>
@@ -16584,7 +16584,7 @@
               </a:spcBef>
               <a:defRPr sz="1100">
                 <a:solidFill>
-                  <a:srgbClr val="F4F8FC"/>
+                  <a:srgbClr val="151515"/>
                 </a:solidFill>
               </a:defRPr>
             </a:pPr>
@@ -16609,7 +16609,7 @@
             <a:avLst/>
           </a:prstGeom>
           <a:solidFill>
-            <a:srgbClr val="46D6C8"/>
+            <a:srgbClr val="E6462E"/>
           </a:solidFill>
           <a:ln>
             <a:noFill/>
@@ -16652,7 +16652,7 @@
             <a:avLst/>
           </a:prstGeom>
           <a:solidFill>
-            <a:srgbClr val="10243C"/>
+            <a:srgbClr val="FFFFFF"/>
           </a:solidFill>
           <a:ln>
             <a:solidFill>
@@ -16681,7 +16681,7 @@
             <a:pPr algn="ctr">
               <a:defRPr sz="1200" b="1">
                 <a:solidFill>
-                  <a:srgbClr val="55A7FF"/>
+                  <a:srgbClr val="176B87"/>
                 </a:solidFill>
               </a:defRPr>
             </a:pPr>
@@ -16696,7 +16696,7 @@
               </a:spcBef>
               <a:defRPr sz="1100">
                 <a:solidFill>
-                  <a:srgbClr val="F4F8FC"/>
+                  <a:srgbClr val="151515"/>
                 </a:solidFill>
               </a:defRPr>
             </a:pPr>
@@ -16721,7 +16721,7 @@
             <a:avLst/>
           </a:prstGeom>
           <a:solidFill>
-            <a:srgbClr val="55A7FF"/>
+            <a:srgbClr val="176B87"/>
           </a:solidFill>
           <a:ln>
             <a:noFill/>
@@ -16764,7 +16764,7 @@
             <a:avLst/>
           </a:prstGeom>
           <a:solidFill>
-            <a:srgbClr val="10243C"/>
+            <a:srgbClr val="FFFFFF"/>
           </a:solidFill>
           <a:ln>
             <a:solidFill>
@@ -16793,7 +16793,7 @@
             <a:pPr algn="ctr">
               <a:defRPr sz="1200" b="1">
                 <a:solidFill>
-                  <a:srgbClr val="FFBE55"/>
+                  <a:srgbClr val="D39A28"/>
                 </a:solidFill>
               </a:defRPr>
             </a:pPr>
@@ -16808,7 +16808,7 @@
               </a:spcBef>
               <a:defRPr sz="1100">
                 <a:solidFill>
-                  <a:srgbClr val="F4F8FC"/>
+                  <a:srgbClr val="151515"/>
                 </a:solidFill>
               </a:defRPr>
             </a:pPr>
@@ -16833,7 +16833,7 @@
             <a:avLst/>
           </a:prstGeom>
           <a:solidFill>
-            <a:srgbClr val="FFBE55"/>
+            <a:srgbClr val="D39A28"/>
           </a:solidFill>
           <a:ln>
             <a:noFill/>
@@ -16876,7 +16876,7 @@
             <a:avLst/>
           </a:prstGeom>
           <a:solidFill>
-            <a:srgbClr val="10243C"/>
+            <a:srgbClr val="FFFFFF"/>
           </a:solidFill>
           <a:ln>
             <a:solidFill>
@@ -16905,7 +16905,7 @@
             <a:pPr algn="ctr">
               <a:defRPr sz="1200" b="1">
                 <a:solidFill>
-                  <a:srgbClr val="46D6C8"/>
+                  <a:srgbClr val="E6462E"/>
                 </a:solidFill>
               </a:defRPr>
             </a:pPr>
@@ -16920,7 +16920,7 @@
               </a:spcBef>
               <a:defRPr sz="1100">
                 <a:solidFill>
-                  <a:srgbClr val="F4F8FC"/>
+                  <a:srgbClr val="151515"/>
                 </a:solidFill>
               </a:defRPr>
             </a:pPr>
@@ -16945,7 +16945,7 @@
             <a:avLst/>
           </a:prstGeom>
           <a:solidFill>
-            <a:srgbClr val="46D6C8"/>
+            <a:srgbClr val="E6462E"/>
           </a:solidFill>
           <a:ln>
             <a:noFill/>
@@ -16998,7 +16998,7 @@
             <a:pPr>
               <a:defRPr sz="900">
                 <a:solidFill>
-                  <a:srgbClr val="9AB2C8"/>
+                  <a:srgbClr val="62666A"/>
                 </a:solidFill>
               </a:defRPr>
             </a:pPr>

</xml_diff>